<commit_message>
PPTX nativo com texto editavel, e uma capa
Antes o pptx era so uma imagem por slide, entao nada podia ser corrigido no
PowerPoint. Agora gerar_pptx.py monta tudo com caixas de texto e formas
nativas: negrito e italico por trecho, barras empilhadas como retangulos,
cartoes com borda e barra de acento. So o histograma continua figura, porque
e um grafico.

Acrescenta uma capa. O nome do colega ficou como "(preencher o nome do
colega)" -- nao invento nome de pessoa numa entrega academica.

Usa Arial em vez de Helvetica Neue: existe no Mac e no Windows, entao o
arquivo nao troca de fonte na maquina de outra pessoa.

Os numeros vem de numeros.json, o mesmo arquivo que alimenta os slides em
HTML, para PDF e PPTX nunca divergirem.

Tres ajustes de layout achados renderizando os slides com o qlmanage: duas
caixas estavam curtas e o texto passava da borda, e a figura do slide 3
cobria o rodape.

Co-Authored-By: Claude Fable 5 <noreply@anthropic.com>
</commit_message>
<xml_diff>
--- a/apresentacao/apresentacao.pptx
+++ b/apresentacao/apresentacao.pptx
@@ -8,8 +8,9 @@
     <p:sldId id="256" r:id="rId7"/>
     <p:sldId id="257" r:id="rId8"/>
     <p:sldId id="258" r:id="rId9"/>
+    <p:sldId id="259" r:id="rId10"/>
   </p:sldIdLst>
-  <p:sldSz cx="12192000" cy="6858000" type="screen4x3"/>
+  <p:sldSz cx="12191695" cy="6858000" type="screen4x3"/>
   <p:notesSz cx="6858000" cy="9144000"/>
   <p:defaultTextStyle>
     <a:defPPr>
@@ -3090,30 +3091,357 @@
         <p:nvPr/>
       </p:nvGrpSpPr>
       <p:grpSpPr/>
-      <p:pic>
-        <p:nvPicPr>
-          <p:cNvPr id="2" name="Picture 1" descr="slide1.png"/>
-          <p:cNvPicPr>
-            <a:picLocks noChangeAspect="1"/>
-          </p:cNvPicPr>
-          <p:nvPr/>
-        </p:nvPicPr>
-        <p:blipFill>
-          <a:blip r:embed="rId2"/>
-          <a:stretch>
-            <a:fillRect/>
-          </a:stretch>
-        </p:blipFill>
+      <p:sp>
+        <p:nvSpPr>
+          <p:cNvPr id="2" name="Rectangle 1"/>
+          <p:cNvSpPr/>
+          <p:nvPr/>
+        </p:nvSpPr>
         <p:spPr>
           <a:xfrm>
             <a:off x="0" y="0"/>
-            <a:ext cx="12192000" cy="6858000"/>
+            <a:ext cx="12191695" cy="6858000"/>
           </a:xfrm>
           <a:prstGeom prst="rect">
             <a:avLst/>
           </a:prstGeom>
-        </p:spPr>
-      </p:pic>
+          <a:solidFill>
+            <a:srgbClr val="FCFCFB"/>
+          </a:solidFill>
+          <a:ln>
+            <a:noFill/>
+          </a:ln>
+          <a:effectLst/>
+        </p:spPr>
+        <p:style>
+          <a:lnRef idx="1">
+            <a:schemeClr val="accent1"/>
+          </a:lnRef>
+          <a:fillRef idx="3">
+            <a:schemeClr val="accent1"/>
+          </a:fillRef>
+          <a:effectRef idx="2">
+            <a:schemeClr val="accent1"/>
+          </a:effectRef>
+          <a:fontRef idx="minor">
+            <a:schemeClr val="lt1"/>
+          </a:fontRef>
+        </p:style>
+        <p:txBody>
+          <a:bodyPr rtlCol="0" anchor="ctr"/>
+          <a:lstStyle/>
+          <a:p/>
+        </p:txBody>
+      </p:sp>
+      <p:sp>
+        <p:nvSpPr>
+          <p:cNvPr id="3" name="Rectangle 2"/>
+          <p:cNvSpPr/>
+          <p:nvPr/>
+        </p:nvSpPr>
+        <p:spPr>
+          <a:xfrm>
+            <a:off x="640080" y="1965960"/>
+            <a:ext cx="1371600" cy="64008"/>
+          </a:xfrm>
+          <a:prstGeom prst="rect">
+            <a:avLst/>
+          </a:prstGeom>
+          <a:solidFill>
+            <a:srgbClr val="3987E5"/>
+          </a:solidFill>
+          <a:ln>
+            <a:noFill/>
+          </a:ln>
+          <a:effectLst/>
+        </p:spPr>
+        <p:style>
+          <a:lnRef idx="1">
+            <a:schemeClr val="accent1"/>
+          </a:lnRef>
+          <a:fillRef idx="3">
+            <a:schemeClr val="accent1"/>
+          </a:fillRef>
+          <a:effectRef idx="2">
+            <a:schemeClr val="accent1"/>
+          </a:effectRef>
+          <a:fontRef idx="minor">
+            <a:schemeClr val="lt1"/>
+          </a:fontRef>
+        </p:style>
+        <p:txBody>
+          <a:bodyPr rtlCol="0" anchor="ctr"/>
+          <a:lstStyle/>
+          <a:p/>
+        </p:txBody>
+      </p:sp>
+      <p:sp>
+        <p:nvSpPr>
+          <p:cNvPr id="4" name="TextBox 3"/>
+          <p:cNvSpPr txBox="1"/>
+          <p:nvPr/>
+        </p:nvSpPr>
+        <p:spPr>
+          <a:xfrm>
+            <a:off x="640080" y="2286000"/>
+            <a:ext cx="9601200" cy="1371600"/>
+          </a:xfrm>
+          <a:prstGeom prst="rect">
+            <a:avLst/>
+          </a:prstGeom>
+          <a:noFill/>
+        </p:spPr>
+        <p:txBody>
+          <a:bodyPr wrap="square" anchor="t" lIns="0" rIns="0" tIns="0" bIns="0">
+            <a:spAutoFit/>
+          </a:bodyPr>
+          <a:lstStyle/>
+          <a:p>
+            <a:pPr algn="l">
+              <a:lnSpc>
+                <a:spcPct val="112000"/>
+              </a:lnSpc>
+            </a:pPr>
+            <a:r>
+              <a:rPr b="1" sz="4000">
+                <a:solidFill>
+                  <a:srgbClr val="0B0B0B"/>
+                </a:solidFill>
+                <a:latin typeface="Arial"/>
+              </a:rPr>
+              <a:t>Do que as pessoas falam</a:t>
+            </a:r>
+          </a:p>
+          <a:p>
+            <a:pPr algn="l">
+              <a:lnSpc>
+                <a:spcPct val="112000"/>
+              </a:lnSpc>
+              <a:spcBef>
+                <a:spcPts val="600"/>
+              </a:spcBef>
+            </a:pPr>
+            <a:r>
+              <a:rPr b="1" sz="4000">
+                <a:solidFill>
+                  <a:srgbClr val="0B0B0B"/>
+                </a:solidFill>
+                <a:latin typeface="Arial"/>
+              </a:rPr>
+              <a:t>quando falam da Argentina</a:t>
+            </a:r>
+          </a:p>
+        </p:txBody>
+      </p:sp>
+      <p:sp>
+        <p:nvSpPr>
+          <p:cNvPr id="5" name="TextBox 4"/>
+          <p:cNvSpPr txBox="1"/>
+          <p:nvPr/>
+        </p:nvSpPr>
+        <p:spPr>
+          <a:xfrm>
+            <a:off x="640080" y="3977639"/>
+            <a:ext cx="8686800" cy="822960"/>
+          </a:xfrm>
+          <a:prstGeom prst="rect">
+            <a:avLst/>
+          </a:prstGeom>
+          <a:noFill/>
+        </p:spPr>
+        <p:txBody>
+          <a:bodyPr wrap="square" anchor="t" lIns="0" rIns="0" tIns="0" bIns="0">
+            <a:spAutoFit/>
+          </a:bodyPr>
+          <a:lstStyle/>
+          <a:p>
+            <a:pPr algn="l">
+              <a:lnSpc>
+                <a:spcPct val="140000"/>
+              </a:lnSpc>
+            </a:pPr>
+            <a:r>
+              <a:rPr b="0" sz="1500">
+                <a:solidFill>
+                  <a:srgbClr val="898781"/>
+                </a:solidFill>
+                <a:latin typeface="Arial"/>
+              </a:rPr>
+              <a:t>Análise de sentimento de posts de rede social com o dicionário ANEW</a:t>
+            </a:r>
+          </a:p>
+          <a:p>
+            <a:pPr algn="l">
+              <a:lnSpc>
+                <a:spcPct val="140000"/>
+              </a:lnSpc>
+              <a:spcBef>
+                <a:spcPts val="600"/>
+              </a:spcBef>
+            </a:pPr>
+            <a:r>
+              <a:rPr b="0" sz="1500">
+                <a:solidFill>
+                  <a:srgbClr val="898781"/>
+                </a:solidFill>
+                <a:latin typeface="Arial"/>
+              </a:rPr>
+              <a:t>de normas afetivas (Bradley &amp; Lang, 1999)</a:t>
+            </a:r>
+          </a:p>
+        </p:txBody>
+      </p:sp>
+      <p:cxnSp>
+        <p:nvCxnSpPr>
+          <p:cNvPr id="6" name="Connector 5"/>
+          <p:cNvCxnSpPr/>
+          <p:nvPr/>
+        </p:nvCxnSpPr>
+        <p:spPr>
+          <a:xfrm>
+            <a:off x="640080" y="5120640"/>
+            <a:ext cx="4754880" cy="0"/>
+          </a:xfrm>
+          <a:prstGeom prst="line">
+            <a:avLst/>
+          </a:prstGeom>
+          <a:ln w="9525">
+            <a:solidFill>
+              <a:srgbClr val="E1E0D9"/>
+            </a:solidFill>
+          </a:ln>
+        </p:spPr>
+        <p:style>
+          <a:lnRef idx="2">
+            <a:schemeClr val="accent1"/>
+          </a:lnRef>
+          <a:fillRef idx="0">
+            <a:schemeClr val="accent1"/>
+          </a:fillRef>
+          <a:effectRef idx="1">
+            <a:schemeClr val="accent1"/>
+          </a:effectRef>
+          <a:fontRef idx="minor">
+            <a:schemeClr val="tx1"/>
+          </a:fontRef>
+        </p:style>
+      </p:cxnSp>
+      <p:sp>
+        <p:nvSpPr>
+          <p:cNvPr id="7" name="TextBox 6"/>
+          <p:cNvSpPr txBox="1"/>
+          <p:nvPr/>
+        </p:nvSpPr>
+        <p:spPr>
+          <a:xfrm>
+            <a:off x="640080" y="5349240"/>
+            <a:ext cx="5029200" cy="731520"/>
+          </a:xfrm>
+          <a:prstGeom prst="rect">
+            <a:avLst/>
+          </a:prstGeom>
+          <a:noFill/>
+        </p:spPr>
+        <p:txBody>
+          <a:bodyPr wrap="square" anchor="t" lIns="0" rIns="0" tIns="0" bIns="0">
+            <a:spAutoFit/>
+          </a:bodyPr>
+          <a:lstStyle/>
+          <a:p>
+            <a:pPr algn="l">
+              <a:lnSpc>
+                <a:spcPct val="140000"/>
+              </a:lnSpc>
+            </a:pPr>
+            <a:r>
+              <a:rPr b="0" sz="1250">
+                <a:solidFill>
+                  <a:srgbClr val="52514E"/>
+                </a:solidFill>
+                <a:latin typeface="Arial"/>
+              </a:rPr>
+              <a:t>Pedro Fardin</a:t>
+            </a:r>
+          </a:p>
+          <a:p>
+            <a:pPr algn="l">
+              <a:lnSpc>
+                <a:spcPct val="140000"/>
+              </a:lnSpc>
+              <a:spcBef>
+                <a:spcPts val="600"/>
+              </a:spcBef>
+            </a:pPr>
+            <a:r>
+              <a:rPr b="0" sz="1250">
+                <a:solidFill>
+                  <a:srgbClr val="52514E"/>
+                </a:solidFill>
+                <a:latin typeface="Arial"/>
+              </a:rPr>
+              <a:t>(preencher o nome do colega)</a:t>
+            </a:r>
+          </a:p>
+        </p:txBody>
+      </p:sp>
+      <p:sp>
+        <p:nvSpPr>
+          <p:cNvPr id="8" name="TextBox 7"/>
+          <p:cNvSpPr txBox="1"/>
+          <p:nvPr/>
+        </p:nvSpPr>
+        <p:spPr>
+          <a:xfrm>
+            <a:off x="6583680" y="5349240"/>
+            <a:ext cx="4937760" cy="731520"/>
+          </a:xfrm>
+          <a:prstGeom prst="rect">
+            <a:avLst/>
+          </a:prstGeom>
+          <a:noFill/>
+        </p:spPr>
+        <p:txBody>
+          <a:bodyPr wrap="square" anchor="t" lIns="0" rIns="0" tIns="0" bIns="0">
+            <a:spAutoFit/>
+          </a:bodyPr>
+          <a:lstStyle/>
+          <a:p>
+            <a:pPr algn="l">
+              <a:lnSpc>
+                <a:spcPct val="140000"/>
+              </a:lnSpc>
+            </a:pPr>
+            <a:r>
+              <a:rPr b="0" sz="1250">
+                <a:solidFill>
+                  <a:srgbClr val="898781"/>
+                </a:solidFill>
+                <a:latin typeface="Arial"/>
+              </a:rPr>
+              <a:t>Processamento de Linguagem Natural</a:t>
+            </a:r>
+          </a:p>
+          <a:p>
+            <a:pPr algn="l">
+              <a:lnSpc>
+                <a:spcPct val="140000"/>
+              </a:lnSpc>
+              <a:spcBef>
+                <a:spcPts val="600"/>
+              </a:spcBef>
+            </a:pPr>
+            <a:r>
+              <a:rPr b="0" sz="1250">
+                <a:solidFill>
+                  <a:srgbClr val="898781"/>
+                </a:solidFill>
+                <a:latin typeface="Arial"/>
+              </a:rPr>
+              <a:t>2.400 posts do Mastodon · agosto de 2026</a:t>
+            </a:r>
+          </a:p>
+        </p:txBody>
+      </p:sp>
     </p:spTree>
   </p:cSld>
   <p:clrMapOvr>
@@ -3132,30 +3460,1226 @@
         <p:nvPr/>
       </p:nvGrpSpPr>
       <p:grpSpPr/>
-      <p:pic>
-        <p:nvPicPr>
-          <p:cNvPr id="2" name="Picture 1" descr="slide2.png"/>
-          <p:cNvPicPr>
-            <a:picLocks noChangeAspect="1"/>
-          </p:cNvPicPr>
-          <p:nvPr/>
-        </p:nvPicPr>
-        <p:blipFill>
-          <a:blip r:embed="rId2"/>
-          <a:stretch>
-            <a:fillRect/>
-          </a:stretch>
-        </p:blipFill>
+      <p:sp>
+        <p:nvSpPr>
+          <p:cNvPr id="2" name="Rectangle 1"/>
+          <p:cNvSpPr/>
+          <p:nvPr/>
+        </p:nvSpPr>
         <p:spPr>
           <a:xfrm>
             <a:off x="0" y="0"/>
-            <a:ext cx="12192000" cy="6858000"/>
+            <a:ext cx="12191695" cy="6858000"/>
           </a:xfrm>
           <a:prstGeom prst="rect">
             <a:avLst/>
           </a:prstGeom>
-        </p:spPr>
-      </p:pic>
+          <a:solidFill>
+            <a:srgbClr val="FCFCFB"/>
+          </a:solidFill>
+          <a:ln>
+            <a:noFill/>
+          </a:ln>
+          <a:effectLst/>
+        </p:spPr>
+        <p:style>
+          <a:lnRef idx="1">
+            <a:schemeClr val="accent1"/>
+          </a:lnRef>
+          <a:fillRef idx="3">
+            <a:schemeClr val="accent1"/>
+          </a:fillRef>
+          <a:effectRef idx="2">
+            <a:schemeClr val="accent1"/>
+          </a:effectRef>
+          <a:fontRef idx="minor">
+            <a:schemeClr val="lt1"/>
+          </a:fontRef>
+        </p:style>
+        <p:txBody>
+          <a:bodyPr rtlCol="0" anchor="ctr"/>
+          <a:lstStyle/>
+          <a:p/>
+        </p:txBody>
+      </p:sp>
+      <p:sp>
+        <p:nvSpPr>
+          <p:cNvPr id="3" name="TextBox 2"/>
+          <p:cNvSpPr txBox="1"/>
+          <p:nvPr/>
+        </p:nvSpPr>
+        <p:spPr>
+          <a:xfrm>
+            <a:off x="640080" y="502920"/>
+            <a:ext cx="10911535" cy="548640"/>
+          </a:xfrm>
+          <a:prstGeom prst="rect">
+            <a:avLst/>
+          </a:prstGeom>
+          <a:noFill/>
+        </p:spPr>
+        <p:txBody>
+          <a:bodyPr wrap="square" lIns="0" rIns="0" tIns="0" bIns="0">
+            <a:spAutoFit/>
+          </a:bodyPr>
+          <a:lstStyle/>
+          <a:p>
+            <a:pPr>
+              <a:lnSpc>
+                <a:spcPct val="110000"/>
+              </a:lnSpc>
+            </a:pPr>
+            <a:r>
+              <a:rPr sz="2700" b="1">
+                <a:solidFill>
+                  <a:srgbClr val="0B0B0B"/>
+                </a:solidFill>
+                <a:latin typeface="Arial"/>
+              </a:rPr>
+              <a:t>Como decidimos se um post fala bem ou mal da Argentina</a:t>
+            </a:r>
+          </a:p>
+        </p:txBody>
+      </p:sp>
+      <p:sp>
+        <p:nvSpPr>
+          <p:cNvPr id="4" name="TextBox 3"/>
+          <p:cNvSpPr txBox="1"/>
+          <p:nvPr/>
+        </p:nvSpPr>
+        <p:spPr>
+          <a:xfrm>
+            <a:off x="640080" y="1078992"/>
+            <a:ext cx="10911535" cy="457200"/>
+          </a:xfrm>
+          <a:prstGeom prst="rect">
+            <a:avLst/>
+          </a:prstGeom>
+          <a:noFill/>
+        </p:spPr>
+        <p:txBody>
+          <a:bodyPr wrap="square" anchor="t" lIns="0" rIns="0" tIns="0" bIns="0">
+            <a:spAutoFit/>
+          </a:bodyPr>
+          <a:lstStyle/>
+          <a:p>
+            <a:pPr algn="l">
+              <a:lnSpc>
+                <a:spcPct val="130000"/>
+              </a:lnSpc>
+            </a:pPr>
+            <a:r>
+              <a:rPr b="0" sz="1250">
+                <a:solidFill>
+                  <a:srgbClr val="898781"/>
+                </a:solidFill>
+                <a:latin typeface="Arial"/>
+              </a:rPr>
+              <a:t>Cada palavra do dicionário ANEW já vem com uma nota de agrado, dada por voluntários. A nota de um post é a média das notas das suas palavras.</a:t>
+            </a:r>
+          </a:p>
+        </p:txBody>
+      </p:sp>
+      <p:sp>
+        <p:nvSpPr>
+          <p:cNvPr id="5" name="Oval 4"/>
+          <p:cNvSpPr/>
+          <p:nvPr/>
+        </p:nvSpPr>
+        <p:spPr>
+          <a:xfrm>
+            <a:off x="640080" y="1965960"/>
+            <a:ext cx="310896" cy="310896"/>
+          </a:xfrm>
+          <a:prstGeom prst="ellipse">
+            <a:avLst/>
+          </a:prstGeom>
+          <a:solidFill>
+            <a:srgbClr val="0B0B0B"/>
+          </a:solidFill>
+          <a:ln>
+            <a:noFill/>
+          </a:ln>
+          <a:effectLst/>
+        </p:spPr>
+        <p:style>
+          <a:lnRef idx="1">
+            <a:schemeClr val="accent1"/>
+          </a:lnRef>
+          <a:fillRef idx="3">
+            <a:schemeClr val="accent1"/>
+          </a:fillRef>
+          <a:effectRef idx="2">
+            <a:schemeClr val="accent1"/>
+          </a:effectRef>
+          <a:fontRef idx="minor">
+            <a:schemeClr val="lt1"/>
+          </a:fontRef>
+        </p:style>
+        <p:txBody>
+          <a:bodyPr rtlCol="0" anchor="ctr" lIns="0" rIns="0" tIns="0" bIns="0"/>
+          <a:lstStyle/>
+          <a:p>
+            <a:pPr algn="ctr"/>
+            <a:r>
+              <a:rPr sz="1200" b="1">
+                <a:solidFill>
+                  <a:srgbClr val="FCFCFB"/>
+                </a:solidFill>
+                <a:latin typeface="Arial"/>
+              </a:rPr>
+              <a:t>1</a:t>
+            </a:r>
+          </a:p>
+        </p:txBody>
+      </p:sp>
+      <p:sp>
+        <p:nvSpPr>
+          <p:cNvPr id="6" name="TextBox 5"/>
+          <p:cNvSpPr txBox="1"/>
+          <p:nvPr/>
+        </p:nvSpPr>
+        <p:spPr>
+          <a:xfrm>
+            <a:off x="1097280" y="1947672"/>
+            <a:ext cx="4937760" cy="274320"/>
+          </a:xfrm>
+          <a:prstGeom prst="rect">
+            <a:avLst/>
+          </a:prstGeom>
+          <a:noFill/>
+        </p:spPr>
+        <p:txBody>
+          <a:bodyPr wrap="square" anchor="t" lIns="0" rIns="0" tIns="0" bIns="0">
+            <a:spAutoFit/>
+          </a:bodyPr>
+          <a:lstStyle/>
+          <a:p>
+            <a:pPr algn="l">
+              <a:lnSpc>
+                <a:spcPct val="125000"/>
+              </a:lnSpc>
+            </a:pPr>
+            <a:r>
+              <a:rPr b="1" sz="1450">
+                <a:solidFill>
+                  <a:srgbClr val="0B0B0B"/>
+                </a:solidFill>
+                <a:latin typeface="Arial"/>
+              </a:rPr>
+              <a:t>Buscamos os posts</a:t>
+            </a:r>
+          </a:p>
+        </p:txBody>
+      </p:sp>
+      <p:sp>
+        <p:nvSpPr>
+          <p:cNvPr id="7" name="TextBox 6"/>
+          <p:cNvSpPr txBox="1"/>
+          <p:nvPr/>
+        </p:nvSpPr>
+        <p:spPr>
+          <a:xfrm>
+            <a:off x="1097280" y="2221992"/>
+            <a:ext cx="4937760" cy="822960"/>
+          </a:xfrm>
+          <a:prstGeom prst="rect">
+            <a:avLst/>
+          </a:prstGeom>
+          <a:noFill/>
+        </p:spPr>
+        <p:txBody>
+          <a:bodyPr wrap="square" anchor="t" lIns="0" rIns="0" tIns="0" bIns="0">
+            <a:spAutoFit/>
+          </a:bodyPr>
+          <a:lstStyle/>
+          <a:p>
+            <a:pPr algn="l">
+              <a:lnSpc>
+                <a:spcPct val="130000"/>
+              </a:lnSpc>
+            </a:pPr>
+            <a:r>
+              <a:rPr b="0" sz="1150">
+                <a:solidFill>
+                  <a:srgbClr val="52514E"/>
+                </a:solidFill>
+                <a:latin typeface="Arial"/>
+              </a:rPr>
+              <a:t>Um programa nosso baixa da API do Mastodon os posts que citam </a:t>
+            </a:r>
+            <a:r>
+              <a:rPr b="1" sz="1150">
+                <a:solidFill>
+                  <a:srgbClr val="0B0B0B"/>
+                </a:solidFill>
+                <a:latin typeface="Arial"/>
+              </a:rPr>
+              <a:t>Argentina</a:t>
+            </a:r>
+            <a:r>
+              <a:rPr b="0" sz="1150">
+                <a:solidFill>
+                  <a:srgbClr val="52514E"/>
+                </a:solidFill>
+                <a:latin typeface="Arial"/>
+              </a:rPr>
+              <a:t>, e confere o idioma de cada um.</a:t>
+            </a:r>
+          </a:p>
+        </p:txBody>
+      </p:sp>
+      <p:sp>
+        <p:nvSpPr>
+          <p:cNvPr id="8" name="Oval 7"/>
+          <p:cNvSpPr/>
+          <p:nvPr/>
+        </p:nvSpPr>
+        <p:spPr>
+          <a:xfrm>
+            <a:off x="640080" y="3017520"/>
+            <a:ext cx="310896" cy="310896"/>
+          </a:xfrm>
+          <a:prstGeom prst="ellipse">
+            <a:avLst/>
+          </a:prstGeom>
+          <a:solidFill>
+            <a:srgbClr val="0B0B0B"/>
+          </a:solidFill>
+          <a:ln>
+            <a:noFill/>
+          </a:ln>
+          <a:effectLst/>
+        </p:spPr>
+        <p:style>
+          <a:lnRef idx="1">
+            <a:schemeClr val="accent1"/>
+          </a:lnRef>
+          <a:fillRef idx="3">
+            <a:schemeClr val="accent1"/>
+          </a:fillRef>
+          <a:effectRef idx="2">
+            <a:schemeClr val="accent1"/>
+          </a:effectRef>
+          <a:fontRef idx="minor">
+            <a:schemeClr val="lt1"/>
+          </a:fontRef>
+        </p:style>
+        <p:txBody>
+          <a:bodyPr rtlCol="0" anchor="ctr" lIns="0" rIns="0" tIns="0" bIns="0"/>
+          <a:lstStyle/>
+          <a:p>
+            <a:pPr algn="ctr"/>
+            <a:r>
+              <a:rPr sz="1200" b="1">
+                <a:solidFill>
+                  <a:srgbClr val="FCFCFB"/>
+                </a:solidFill>
+                <a:latin typeface="Arial"/>
+              </a:rPr>
+              <a:t>2</a:t>
+            </a:r>
+          </a:p>
+        </p:txBody>
+      </p:sp>
+      <p:sp>
+        <p:nvSpPr>
+          <p:cNvPr id="9" name="TextBox 8"/>
+          <p:cNvSpPr txBox="1"/>
+          <p:nvPr/>
+        </p:nvSpPr>
+        <p:spPr>
+          <a:xfrm>
+            <a:off x="1097280" y="2999232"/>
+            <a:ext cx="4937760" cy="274320"/>
+          </a:xfrm>
+          <a:prstGeom prst="rect">
+            <a:avLst/>
+          </a:prstGeom>
+          <a:noFill/>
+        </p:spPr>
+        <p:txBody>
+          <a:bodyPr wrap="square" anchor="t" lIns="0" rIns="0" tIns="0" bIns="0">
+            <a:spAutoFit/>
+          </a:bodyPr>
+          <a:lstStyle/>
+          <a:p>
+            <a:pPr algn="l">
+              <a:lnSpc>
+                <a:spcPct val="125000"/>
+              </a:lnSpc>
+            </a:pPr>
+            <a:r>
+              <a:rPr b="1" sz="1450">
+                <a:solidFill>
+                  <a:srgbClr val="0B0B0B"/>
+                </a:solidFill>
+                <a:latin typeface="Arial"/>
+              </a:rPr>
+              <a:t>Casamos as palavras com o dicionário</a:t>
+            </a:r>
+          </a:p>
+        </p:txBody>
+      </p:sp>
+      <p:sp>
+        <p:nvSpPr>
+          <p:cNvPr id="10" name="TextBox 9"/>
+          <p:cNvSpPr txBox="1"/>
+          <p:nvPr/>
+        </p:nvSpPr>
+        <p:spPr>
+          <a:xfrm>
+            <a:off x="1097280" y="3273552"/>
+            <a:ext cx="4937760" cy="822960"/>
+          </a:xfrm>
+          <a:prstGeom prst="rect">
+            <a:avLst/>
+          </a:prstGeom>
+          <a:noFill/>
+        </p:spPr>
+        <p:txBody>
+          <a:bodyPr wrap="square" anchor="t" lIns="0" rIns="0" tIns="0" bIns="0">
+            <a:spAutoFit/>
+          </a:bodyPr>
+          <a:lstStyle/>
+          <a:p>
+            <a:pPr algn="l">
+              <a:lnSpc>
+                <a:spcPct val="130000"/>
+              </a:lnSpc>
+            </a:pPr>
+            <a:r>
+              <a:rPr b="0" sz="1150">
+                <a:solidFill>
+                  <a:srgbClr val="52514E"/>
+                </a:solidFill>
+                <a:latin typeface="Arial"/>
+              </a:rPr>
+              <a:t>As 1.034 palavras do ANEW têm nota de 0 a 100. </a:t>
+            </a:r>
+            <a:r>
+              <a:rPr b="1" sz="1150">
+                <a:solidFill>
+                  <a:srgbClr val="0B0B0B"/>
+                </a:solidFill>
+                <a:latin typeface="Arial"/>
+              </a:rPr>
+              <a:t>love</a:t>
+            </a:r>
+            <a:r>
+              <a:rPr b="0" sz="1150">
+                <a:solidFill>
+                  <a:srgbClr val="52514E"/>
+                </a:solidFill>
+                <a:latin typeface="Arial"/>
+              </a:rPr>
+              <a:t> = 99 · </a:t>
+            </a:r>
+            <a:r>
+              <a:rPr b="1" sz="1150">
+                <a:solidFill>
+                  <a:srgbClr val="0B0B0B"/>
+                </a:solidFill>
+                <a:latin typeface="Arial"/>
+              </a:rPr>
+              <a:t>news</a:t>
+            </a:r>
+            <a:r>
+              <a:rPr b="0" sz="1150">
+                <a:solidFill>
+                  <a:srgbClr val="52514E"/>
+                </a:solidFill>
+                <a:latin typeface="Arial"/>
+              </a:rPr>
+              <a:t> = 60 · </a:t>
+            </a:r>
+            <a:r>
+              <a:rPr b="1" sz="1150">
+                <a:solidFill>
+                  <a:srgbClr val="0B0B0B"/>
+                </a:solidFill>
+                <a:latin typeface="Arial"/>
+              </a:rPr>
+              <a:t>terrible</a:t>
+            </a:r>
+            <a:r>
+              <a:rPr b="0" sz="1150">
+                <a:solidFill>
+                  <a:srgbClr val="52514E"/>
+                </a:solidFill>
+                <a:latin typeface="Arial"/>
+              </a:rPr>
+              <a:t> = 22. Reduzimos cada palavra do post à forma do dicionário, para que </a:t>
+            </a:r>
+            <a:r>
+              <a:rPr i="1" sz="1150">
+                <a:solidFill>
+                  <a:srgbClr val="52514E"/>
+                </a:solidFill>
+                <a:latin typeface="Arial"/>
+              </a:rPr>
+              <a:t>loved</a:t>
+            </a:r>
+            <a:r>
+              <a:rPr b="0" sz="1150">
+                <a:solidFill>
+                  <a:srgbClr val="52514E"/>
+                </a:solidFill>
+                <a:latin typeface="Arial"/>
+              </a:rPr>
+              <a:t> encontre </a:t>
+            </a:r>
+            <a:r>
+              <a:rPr i="1" sz="1150">
+                <a:solidFill>
+                  <a:srgbClr val="52514E"/>
+                </a:solidFill>
+                <a:latin typeface="Arial"/>
+              </a:rPr>
+              <a:t>love</a:t>
+            </a:r>
+            <a:r>
+              <a:rPr b="0" sz="1150">
+                <a:solidFill>
+                  <a:srgbClr val="52514E"/>
+                </a:solidFill>
+                <a:latin typeface="Arial"/>
+              </a:rPr>
+              <a:t>.</a:t>
+            </a:r>
+          </a:p>
+        </p:txBody>
+      </p:sp>
+      <p:sp>
+        <p:nvSpPr>
+          <p:cNvPr id="11" name="Oval 10"/>
+          <p:cNvSpPr/>
+          <p:nvPr/>
+        </p:nvSpPr>
+        <p:spPr>
+          <a:xfrm>
+            <a:off x="640080" y="4297680"/>
+            <a:ext cx="310896" cy="310896"/>
+          </a:xfrm>
+          <a:prstGeom prst="ellipse">
+            <a:avLst/>
+          </a:prstGeom>
+          <a:solidFill>
+            <a:srgbClr val="0B0B0B"/>
+          </a:solidFill>
+          <a:ln>
+            <a:noFill/>
+          </a:ln>
+          <a:effectLst/>
+        </p:spPr>
+        <p:style>
+          <a:lnRef idx="1">
+            <a:schemeClr val="accent1"/>
+          </a:lnRef>
+          <a:fillRef idx="3">
+            <a:schemeClr val="accent1"/>
+          </a:fillRef>
+          <a:effectRef idx="2">
+            <a:schemeClr val="accent1"/>
+          </a:effectRef>
+          <a:fontRef idx="minor">
+            <a:schemeClr val="lt1"/>
+          </a:fontRef>
+        </p:style>
+        <p:txBody>
+          <a:bodyPr rtlCol="0" anchor="ctr" lIns="0" rIns="0" tIns="0" bIns="0"/>
+          <a:lstStyle/>
+          <a:p>
+            <a:pPr algn="ctr"/>
+            <a:r>
+              <a:rPr sz="1200" b="1">
+                <a:solidFill>
+                  <a:srgbClr val="FCFCFB"/>
+                </a:solidFill>
+                <a:latin typeface="Arial"/>
+              </a:rPr>
+              <a:t>3</a:t>
+            </a:r>
+          </a:p>
+        </p:txBody>
+      </p:sp>
+      <p:sp>
+        <p:nvSpPr>
+          <p:cNvPr id="12" name="TextBox 11"/>
+          <p:cNvSpPr txBox="1"/>
+          <p:nvPr/>
+        </p:nvSpPr>
+        <p:spPr>
+          <a:xfrm>
+            <a:off x="1097280" y="4279392"/>
+            <a:ext cx="4937760" cy="274320"/>
+          </a:xfrm>
+          <a:prstGeom prst="rect">
+            <a:avLst/>
+          </a:prstGeom>
+          <a:noFill/>
+        </p:spPr>
+        <p:txBody>
+          <a:bodyPr wrap="square" anchor="t" lIns="0" rIns="0" tIns="0" bIns="0">
+            <a:spAutoFit/>
+          </a:bodyPr>
+          <a:lstStyle/>
+          <a:p>
+            <a:pPr algn="l">
+              <a:lnSpc>
+                <a:spcPct val="125000"/>
+              </a:lnSpc>
+            </a:pPr>
+            <a:r>
+              <a:rPr b="1" sz="1450">
+                <a:solidFill>
+                  <a:srgbClr val="0B0B0B"/>
+                </a:solidFill>
+                <a:latin typeface="Arial"/>
+              </a:rPr>
+              <a:t>Tiramos a média e comparamos</a:t>
+            </a:r>
+          </a:p>
+        </p:txBody>
+      </p:sp>
+      <p:sp>
+        <p:nvSpPr>
+          <p:cNvPr id="13" name="TextBox 12"/>
+          <p:cNvSpPr txBox="1"/>
+          <p:nvPr/>
+        </p:nvSpPr>
+        <p:spPr>
+          <a:xfrm>
+            <a:off x="1097280" y="4553712"/>
+            <a:ext cx="4937760" cy="822960"/>
+          </a:xfrm>
+          <a:prstGeom prst="rect">
+            <a:avLst/>
+          </a:prstGeom>
+          <a:noFill/>
+        </p:spPr>
+        <p:txBody>
+          <a:bodyPr wrap="square" anchor="t" lIns="0" rIns="0" tIns="0" bIns="0">
+            <a:spAutoFit/>
+          </a:bodyPr>
+          <a:lstStyle/>
+          <a:p>
+            <a:pPr algn="l">
+              <a:lnSpc>
+                <a:spcPct val="130000"/>
+              </a:lnSpc>
+            </a:pPr>
+            <a:r>
+              <a:rPr b="0" sz="1150">
+                <a:solidFill>
+                  <a:srgbClr val="52514E"/>
+                </a:solidFill>
+                <a:latin typeface="Arial"/>
+              </a:rPr>
+              <a:t>Acima da média do dicionário é positivo, abaixo é negativo, perto dela é neutro.</a:t>
+            </a:r>
+          </a:p>
+        </p:txBody>
+      </p:sp>
+      <p:sp>
+        <p:nvSpPr>
+          <p:cNvPr id="14" name="Rounded Rectangle 13"/>
+          <p:cNvSpPr/>
+          <p:nvPr/>
+        </p:nvSpPr>
+        <p:spPr>
+          <a:xfrm>
+            <a:off x="6583680" y="1965960"/>
+            <a:ext cx="4983480" cy="1371600"/>
+          </a:xfrm>
+          <a:prstGeom prst="roundRect">
+            <a:avLst/>
+          </a:prstGeom>
+          <a:solidFill>
+            <a:srgbClr val="FFFFFF"/>
+          </a:solidFill>
+          <a:ln w="9525">
+            <a:solidFill>
+              <a:srgbClr val="E1E0D9"/>
+            </a:solidFill>
+          </a:ln>
+          <a:effectLst/>
+        </p:spPr>
+        <p:style>
+          <a:lnRef idx="1">
+            <a:schemeClr val="accent1"/>
+          </a:lnRef>
+          <a:fillRef idx="3">
+            <a:schemeClr val="accent1"/>
+          </a:fillRef>
+          <a:effectRef idx="2">
+            <a:schemeClr val="accent1"/>
+          </a:effectRef>
+          <a:fontRef idx="minor">
+            <a:schemeClr val="lt1"/>
+          </a:fontRef>
+        </p:style>
+        <p:txBody>
+          <a:bodyPr rtlCol="0" anchor="ctr"/>
+          <a:lstStyle/>
+          <a:p/>
+        </p:txBody>
+      </p:sp>
+      <p:sp>
+        <p:nvSpPr>
+          <p:cNvPr id="15" name="TextBox 14"/>
+          <p:cNvSpPr txBox="1"/>
+          <p:nvPr/>
+        </p:nvSpPr>
+        <p:spPr>
+          <a:xfrm>
+            <a:off x="6858000" y="2240280"/>
+            <a:ext cx="4434840" cy="365760"/>
+          </a:xfrm>
+          <a:prstGeom prst="rect">
+            <a:avLst/>
+          </a:prstGeom>
+          <a:noFill/>
+        </p:spPr>
+        <p:txBody>
+          <a:bodyPr wrap="square" anchor="t" lIns="0" rIns="0" tIns="0" bIns="0">
+            <a:spAutoFit/>
+          </a:bodyPr>
+          <a:lstStyle/>
+          <a:p>
+            <a:pPr algn="ctr">
+              <a:lnSpc>
+                <a:spcPct val="125000"/>
+              </a:lnSpc>
+            </a:pPr>
+            <a:r>
+              <a:rPr b="0" sz="1500">
+                <a:solidFill>
+                  <a:srgbClr val="0B0B0B"/>
+                </a:solidFill>
+                <a:latin typeface="Arial"/>
+              </a:rPr>
+              <a:t>nota do post = média das notas das suas palavras</a:t>
+            </a:r>
+          </a:p>
+        </p:txBody>
+      </p:sp>
+      <p:sp>
+        <p:nvSpPr>
+          <p:cNvPr id="16" name="TextBox 15"/>
+          <p:cNvSpPr txBox="1"/>
+          <p:nvPr/>
+        </p:nvSpPr>
+        <p:spPr>
+          <a:xfrm>
+            <a:off x="6858000" y="2715768"/>
+            <a:ext cx="4434840" cy="548640"/>
+          </a:xfrm>
+          <a:prstGeom prst="rect">
+            <a:avLst/>
+          </a:prstGeom>
+          <a:noFill/>
+        </p:spPr>
+        <p:txBody>
+          <a:bodyPr wrap="square" anchor="t" lIns="0" rIns="0" tIns="0" bIns="0">
+            <a:spAutoFit/>
+          </a:bodyPr>
+          <a:lstStyle/>
+          <a:p>
+            <a:pPr algn="ctr">
+              <a:lnSpc>
+                <a:spcPct val="135000"/>
+              </a:lnSpc>
+            </a:pPr>
+            <a:r>
+              <a:rPr b="0" sz="1100">
+                <a:solidFill>
+                  <a:srgbClr val="898781"/>
+                </a:solidFill>
+                <a:latin typeface="Arial"/>
+              </a:rPr>
+              <a:t>“Argentina is </a:t>
+            </a:r>
+            <a:r>
+              <a:rPr b="1" sz="1100">
+                <a:solidFill>
+                  <a:srgbClr val="898781"/>
+                </a:solidFill>
+                <a:latin typeface="Arial"/>
+              </a:rPr>
+              <a:t>beautiful</a:t>
+            </a:r>
+            <a:r>
+              <a:rPr b="0" sz="1100">
+                <a:solidFill>
+                  <a:srgbClr val="898781"/>
+                </a:solidFill>
+                <a:latin typeface="Arial"/>
+              </a:rPr>
+              <a:t>, I </a:t>
+            </a:r>
+            <a:r>
+              <a:rPr b="1" sz="1100">
+                <a:solidFill>
+                  <a:srgbClr val="898781"/>
+                </a:solidFill>
+                <a:latin typeface="Arial"/>
+              </a:rPr>
+              <a:t>love</a:t>
+            </a:r>
+            <a:r>
+              <a:rPr b="0" sz="1100">
+                <a:solidFill>
+                  <a:srgbClr val="898781"/>
+                </a:solidFill>
+                <a:latin typeface="Arial"/>
+              </a:rPr>
+              <a:t> the </a:t>
+            </a:r>
+            <a:r>
+              <a:rPr b="1" sz="1100">
+                <a:solidFill>
+                  <a:srgbClr val="898781"/>
+                </a:solidFill>
+                <a:latin typeface="Arial"/>
+              </a:rPr>
+              <a:t>people</a:t>
+            </a:r>
+            <a:r>
+              <a:rPr b="0" sz="1100">
+                <a:solidFill>
+                  <a:srgbClr val="898781"/>
+                </a:solidFill>
+                <a:latin typeface="Arial"/>
+              </a:rPr>
+              <a:t> and the </a:t>
+            </a:r>
+            <a:r>
+              <a:rPr b="1" sz="1100">
+                <a:solidFill>
+                  <a:srgbClr val="898781"/>
+                </a:solidFill>
+                <a:latin typeface="Arial"/>
+              </a:rPr>
+              <a:t>food</a:t>
+            </a:r>
+            <a:r>
+              <a:rPr b="0" sz="1100">
+                <a:solidFill>
+                  <a:srgbClr val="898781"/>
+                </a:solidFill>
+                <a:latin typeface="Arial"/>
+              </a:rPr>
+              <a:t>”</a:t>
+            </a:r>
+          </a:p>
+          <a:p>
+            <a:pPr algn="ctr">
+              <a:lnSpc>
+                <a:spcPct val="135000"/>
+              </a:lnSpc>
+              <a:spcBef>
+                <a:spcPts val="600"/>
+              </a:spcBef>
+            </a:pPr>
+            <a:r>
+              <a:rPr b="0" sz="1100">
+                <a:solidFill>
+                  <a:srgbClr val="898781"/>
+                </a:solidFill>
+                <a:latin typeface="Arial"/>
+              </a:rPr>
+              <a:t>(86 + 99 + 83 + 87) ÷ 4 = </a:t>
+            </a:r>
+            <a:r>
+              <a:rPr b="1" sz="1100">
+                <a:solidFill>
+                  <a:srgbClr val="898781"/>
+                </a:solidFill>
+                <a:latin typeface="Arial"/>
+              </a:rPr>
+              <a:t>89</a:t>
+            </a:r>
+            <a:r>
+              <a:rPr b="0" sz="1100">
+                <a:solidFill>
+                  <a:srgbClr val="898781"/>
+                </a:solidFill>
+                <a:latin typeface="Arial"/>
+              </a:rPr>
+              <a:t> → positivo</a:t>
+            </a:r>
+          </a:p>
+        </p:txBody>
+      </p:sp>
+      <p:sp>
+        <p:nvSpPr>
+          <p:cNvPr id="17" name="Rounded Rectangle 16"/>
+          <p:cNvSpPr/>
+          <p:nvPr/>
+        </p:nvSpPr>
+        <p:spPr>
+          <a:xfrm>
+            <a:off x="6583680" y="3657600"/>
+            <a:ext cx="4983480" cy="2148840"/>
+          </a:xfrm>
+          <a:prstGeom prst="roundRect">
+            <a:avLst/>
+          </a:prstGeom>
+          <a:solidFill>
+            <a:srgbClr val="FFFFFF"/>
+          </a:solidFill>
+          <a:ln w="9525">
+            <a:solidFill>
+              <a:srgbClr val="E1E0D9"/>
+            </a:solidFill>
+          </a:ln>
+          <a:effectLst/>
+        </p:spPr>
+        <p:style>
+          <a:lnRef idx="1">
+            <a:schemeClr val="accent1"/>
+          </a:lnRef>
+          <a:fillRef idx="3">
+            <a:schemeClr val="accent1"/>
+          </a:fillRef>
+          <a:effectRef idx="2">
+            <a:schemeClr val="accent1"/>
+          </a:effectRef>
+          <a:fontRef idx="minor">
+            <a:schemeClr val="lt1"/>
+          </a:fontRef>
+        </p:style>
+        <p:txBody>
+          <a:bodyPr rtlCol="0" anchor="ctr"/>
+          <a:lstStyle/>
+          <a:p/>
+        </p:txBody>
+      </p:sp>
+      <p:sp>
+        <p:nvSpPr>
+          <p:cNvPr id="18" name="Rectangle 17"/>
+          <p:cNvSpPr/>
+          <p:nvPr/>
+        </p:nvSpPr>
+        <p:spPr>
+          <a:xfrm>
+            <a:off x="6583680" y="3657600"/>
+            <a:ext cx="45720" cy="2148840"/>
+          </a:xfrm>
+          <a:prstGeom prst="rect">
+            <a:avLst/>
+          </a:prstGeom>
+          <a:solidFill>
+            <a:srgbClr val="0B0B0B"/>
+          </a:solidFill>
+          <a:ln>
+            <a:noFill/>
+          </a:ln>
+          <a:effectLst/>
+        </p:spPr>
+        <p:style>
+          <a:lnRef idx="1">
+            <a:schemeClr val="accent1"/>
+          </a:lnRef>
+          <a:fillRef idx="3">
+            <a:schemeClr val="accent1"/>
+          </a:fillRef>
+          <a:effectRef idx="2">
+            <a:schemeClr val="accent1"/>
+          </a:effectRef>
+          <a:fontRef idx="minor">
+            <a:schemeClr val="lt1"/>
+          </a:fontRef>
+        </p:style>
+        <p:txBody>
+          <a:bodyPr rtlCol="0" anchor="ctr"/>
+          <a:lstStyle/>
+          <a:p/>
+        </p:txBody>
+      </p:sp>
+      <p:sp>
+        <p:nvSpPr>
+          <p:cNvPr id="19" name="TextBox 18"/>
+          <p:cNvSpPr txBox="1"/>
+          <p:nvPr/>
+        </p:nvSpPr>
+        <p:spPr>
+          <a:xfrm>
+            <a:off x="6876288" y="3886200"/>
+            <a:ext cx="4434840" cy="228600"/>
+          </a:xfrm>
+          <a:prstGeom prst="rect">
+            <a:avLst/>
+          </a:prstGeom>
+          <a:noFill/>
+        </p:spPr>
+        <p:txBody>
+          <a:bodyPr wrap="square" anchor="t" lIns="0" rIns="0" tIns="0" bIns="0">
+            <a:spAutoFit/>
+          </a:bodyPr>
+          <a:lstStyle/>
+          <a:p>
+            <a:pPr algn="l">
+              <a:lnSpc>
+                <a:spcPct val="125000"/>
+              </a:lnSpc>
+            </a:pPr>
+            <a:r>
+              <a:rPr b="1" sz="900">
+                <a:solidFill>
+                  <a:srgbClr val="898781"/>
+                </a:solidFill>
+                <a:latin typeface="Arial"/>
+              </a:rPr>
+              <a:t>AS TRÊS DIMENSÕES DO ANEW</a:t>
+            </a:r>
+          </a:p>
+        </p:txBody>
+      </p:sp>
+      <p:sp>
+        <p:nvSpPr>
+          <p:cNvPr id="20" name="TextBox 19"/>
+          <p:cNvSpPr txBox="1"/>
+          <p:nvPr/>
+        </p:nvSpPr>
+        <p:spPr>
+          <a:xfrm>
+            <a:off x="6876288" y="4206240"/>
+            <a:ext cx="4416552" cy="1188720"/>
+          </a:xfrm>
+          <a:prstGeom prst="rect">
+            <a:avLst/>
+          </a:prstGeom>
+          <a:noFill/>
+        </p:spPr>
+        <p:txBody>
+          <a:bodyPr wrap="square" anchor="t" lIns="0" rIns="0" tIns="0" bIns="0">
+            <a:spAutoFit/>
+          </a:bodyPr>
+          <a:lstStyle/>
+          <a:p>
+            <a:pPr algn="l">
+              <a:lnSpc>
+                <a:spcPct val="130000"/>
+              </a:lnSpc>
+            </a:pPr>
+            <a:r>
+              <a:rPr b="0" sz="1150">
+                <a:solidFill>
+                  <a:srgbClr val="52514E"/>
+                </a:solidFill>
+                <a:latin typeface="Arial"/>
+              </a:rPr>
+              <a:t>O dicionário mede </a:t>
+            </a:r>
+            <a:r>
+              <a:rPr b="1" sz="1150">
+                <a:solidFill>
+                  <a:srgbClr val="0B0B0B"/>
+                </a:solidFill>
+                <a:latin typeface="Arial"/>
+              </a:rPr>
+              <a:t>Pleasure</a:t>
+            </a:r>
+            <a:r>
+              <a:rPr b="0" sz="1150">
+                <a:solidFill>
+                  <a:srgbClr val="52514E"/>
+                </a:solidFill>
+                <a:latin typeface="Arial"/>
+              </a:rPr>
+              <a:t> (agradável ou desagradável), </a:t>
+            </a:r>
+            <a:r>
+              <a:rPr b="1" sz="1150">
+                <a:solidFill>
+                  <a:srgbClr val="0B0B0B"/>
+                </a:solidFill>
+                <a:latin typeface="Arial"/>
+              </a:rPr>
+              <a:t>Arousal</a:t>
+            </a:r>
+            <a:r>
+              <a:rPr b="0" sz="1150">
+                <a:solidFill>
+                  <a:srgbClr val="52514E"/>
+                </a:solidFill>
+                <a:latin typeface="Arial"/>
+              </a:rPr>
+              <a:t> (calmo ou agitado) e </a:t>
+            </a:r>
+            <a:r>
+              <a:rPr b="1" sz="1150">
+                <a:solidFill>
+                  <a:srgbClr val="0B0B0B"/>
+                </a:solidFill>
+                <a:latin typeface="Arial"/>
+              </a:rPr>
+              <a:t>Dominance</a:t>
+            </a:r>
+            <a:r>
+              <a:rPr b="0" sz="1150">
+                <a:solidFill>
+                  <a:srgbClr val="52514E"/>
+                </a:solidFill>
+                <a:latin typeface="Arial"/>
+              </a:rPr>
+              <a:t> (quanto controle a palavra transmite).</a:t>
+            </a:r>
+          </a:p>
+          <a:p>
+            <a:pPr algn="l">
+              <a:lnSpc>
+                <a:spcPct val="130000"/>
+              </a:lnSpc>
+              <a:spcBef>
+                <a:spcPts val="600"/>
+              </a:spcBef>
+            </a:pPr>
+            <a:r>
+              <a:rPr b="0" sz="1150">
+                <a:solidFill>
+                  <a:srgbClr val="52514E"/>
+                </a:solidFill>
+                <a:latin typeface="Arial"/>
+              </a:rPr>
+              <a:t>Usamos só </a:t>
+            </a:r>
+            <a:r>
+              <a:rPr b="1" sz="1150">
+                <a:solidFill>
+                  <a:srgbClr val="0B0B0B"/>
+                </a:solidFill>
+                <a:latin typeface="Arial"/>
+              </a:rPr>
+              <a:t>Pleasure</a:t>
+            </a:r>
+            <a:r>
+              <a:rPr b="0" sz="1150">
+                <a:solidFill>
+                  <a:srgbClr val="52514E"/>
+                </a:solidFill>
+                <a:latin typeface="Arial"/>
+              </a:rPr>
+              <a:t>, porque é a dimensão que responde “falaram bem ou mal?”. As outras duas medem intensidade e poder, não aprovação.</a:t>
+            </a:r>
+          </a:p>
+        </p:txBody>
+      </p:sp>
+      <p:cxnSp>
+        <p:nvCxnSpPr>
+          <p:cNvPr id="21" name="Connector 20"/>
+          <p:cNvCxnSpPr/>
+          <p:nvPr/>
+        </p:nvCxnSpPr>
+        <p:spPr>
+          <a:xfrm>
+            <a:off x="640080" y="6355080"/>
+            <a:ext cx="10911535" cy="0"/>
+          </a:xfrm>
+          <a:prstGeom prst="line">
+            <a:avLst/>
+          </a:prstGeom>
+          <a:ln w="9525">
+            <a:solidFill>
+              <a:srgbClr val="E1E0D9"/>
+            </a:solidFill>
+          </a:ln>
+        </p:spPr>
+        <p:style>
+          <a:lnRef idx="2">
+            <a:schemeClr val="accent1"/>
+          </a:lnRef>
+          <a:fillRef idx="0">
+            <a:schemeClr val="accent1"/>
+          </a:fillRef>
+          <a:effectRef idx="1">
+            <a:schemeClr val="accent1"/>
+          </a:effectRef>
+          <a:fontRef idx="minor">
+            <a:schemeClr val="tx1"/>
+          </a:fontRef>
+        </p:style>
+      </p:cxnSp>
+      <p:sp>
+        <p:nvSpPr>
+          <p:cNvPr id="22" name="TextBox 21"/>
+          <p:cNvSpPr txBox="1"/>
+          <p:nvPr/>
+        </p:nvSpPr>
+        <p:spPr>
+          <a:xfrm>
+            <a:off x="640080" y="6437376"/>
+            <a:ext cx="10454335" cy="274320"/>
+          </a:xfrm>
+          <a:prstGeom prst="rect">
+            <a:avLst/>
+          </a:prstGeom>
+          <a:noFill/>
+        </p:spPr>
+        <p:txBody>
+          <a:bodyPr wrap="square" anchor="t" lIns="0" rIns="0" tIns="0" bIns="0">
+            <a:spAutoFit/>
+          </a:bodyPr>
+          <a:lstStyle/>
+          <a:p>
+            <a:pPr algn="l">
+              <a:lnSpc>
+                <a:spcPct val="125000"/>
+              </a:lnSpc>
+            </a:pPr>
+            <a:r>
+              <a:rPr b="0" sz="850">
+                <a:solidFill>
+                  <a:srgbClr val="898781"/>
+                </a:solidFill>
+                <a:latin typeface="Arial"/>
+              </a:rPr>
+              <a:t>Dicionário ANEW (Bradley &amp; Lang, 1999) · entidade: Argentina · fonte: Mastodon</a:t>
+            </a:r>
+          </a:p>
+        </p:txBody>
+      </p:sp>
+      <p:sp>
+        <p:nvSpPr>
+          <p:cNvPr id="23" name="TextBox 22"/>
+          <p:cNvSpPr txBox="1"/>
+          <p:nvPr/>
+        </p:nvSpPr>
+        <p:spPr>
+          <a:xfrm>
+            <a:off x="11185855" y="6437376"/>
+            <a:ext cx="365760" cy="274320"/>
+          </a:xfrm>
+          <a:prstGeom prst="rect">
+            <a:avLst/>
+          </a:prstGeom>
+          <a:noFill/>
+        </p:spPr>
+        <p:txBody>
+          <a:bodyPr wrap="square" anchor="t" lIns="0" rIns="0" tIns="0" bIns="0">
+            <a:spAutoFit/>
+          </a:bodyPr>
+          <a:lstStyle/>
+          <a:p>
+            <a:pPr algn="r">
+              <a:lnSpc>
+                <a:spcPct val="125000"/>
+              </a:lnSpc>
+            </a:pPr>
+            <a:r>
+              <a:rPr b="0" sz="850">
+                <a:solidFill>
+                  <a:srgbClr val="898781"/>
+                </a:solidFill>
+                <a:latin typeface="Arial"/>
+              </a:rPr>
+              <a:t>1</a:t>
+            </a:r>
+          </a:p>
+        </p:txBody>
+      </p:sp>
     </p:spTree>
   </p:cSld>
   <p:clrMapOvr>
@@ -3174,9 +4698,1829 @@
         <p:nvPr/>
       </p:nvGrpSpPr>
       <p:grpSpPr/>
+      <p:sp>
+        <p:nvSpPr>
+          <p:cNvPr id="2" name="Rectangle 1"/>
+          <p:cNvSpPr/>
+          <p:nvPr/>
+        </p:nvSpPr>
+        <p:spPr>
+          <a:xfrm>
+            <a:off x="0" y="0"/>
+            <a:ext cx="12191695" cy="6858000"/>
+          </a:xfrm>
+          <a:prstGeom prst="rect">
+            <a:avLst/>
+          </a:prstGeom>
+          <a:solidFill>
+            <a:srgbClr val="FCFCFB"/>
+          </a:solidFill>
+          <a:ln>
+            <a:noFill/>
+          </a:ln>
+          <a:effectLst/>
+        </p:spPr>
+        <p:style>
+          <a:lnRef idx="1">
+            <a:schemeClr val="accent1"/>
+          </a:lnRef>
+          <a:fillRef idx="3">
+            <a:schemeClr val="accent1"/>
+          </a:fillRef>
+          <a:effectRef idx="2">
+            <a:schemeClr val="accent1"/>
+          </a:effectRef>
+          <a:fontRef idx="minor">
+            <a:schemeClr val="lt1"/>
+          </a:fontRef>
+        </p:style>
+        <p:txBody>
+          <a:bodyPr rtlCol="0" anchor="ctr"/>
+          <a:lstStyle/>
+          <a:p/>
+        </p:txBody>
+      </p:sp>
+      <p:sp>
+        <p:nvSpPr>
+          <p:cNvPr id="3" name="TextBox 2"/>
+          <p:cNvSpPr txBox="1"/>
+          <p:nvPr/>
+        </p:nvSpPr>
+        <p:spPr>
+          <a:xfrm>
+            <a:off x="640080" y="502920"/>
+            <a:ext cx="10911535" cy="548640"/>
+          </a:xfrm>
+          <a:prstGeom prst="rect">
+            <a:avLst/>
+          </a:prstGeom>
+          <a:noFill/>
+        </p:spPr>
+        <p:txBody>
+          <a:bodyPr wrap="square" lIns="0" rIns="0" tIns="0" bIns="0">
+            <a:spAutoFit/>
+          </a:bodyPr>
+          <a:lstStyle/>
+          <a:p>
+            <a:pPr>
+              <a:lnSpc>
+                <a:spcPct val="110000"/>
+              </a:lnSpc>
+            </a:pPr>
+            <a:r>
+              <a:rPr sz="2700" b="1">
+                <a:solidFill>
+                  <a:srgbClr val="0B0B0B"/>
+                </a:solidFill>
+                <a:latin typeface="Arial"/>
+              </a:rPr>
+              <a:t>Por que escolhemos assim</a:t>
+            </a:r>
+            <a:r>
+              <a:rPr sz="2700">
+                <a:solidFill>
+                  <a:srgbClr val="898781"/>
+                </a:solidFill>
+                <a:latin typeface="Arial"/>
+              </a:rPr>
+              <a:t>  — três decisões que mudam o resultado</a:t>
+            </a:r>
+          </a:p>
+        </p:txBody>
+      </p:sp>
+      <p:sp>
+        <p:nvSpPr>
+          <p:cNvPr id="4" name="TextBox 3"/>
+          <p:cNvSpPr txBox="1"/>
+          <p:nvPr/>
+        </p:nvSpPr>
+        <p:spPr>
+          <a:xfrm>
+            <a:off x="640080" y="1078992"/>
+            <a:ext cx="10911535" cy="457200"/>
+          </a:xfrm>
+          <a:prstGeom prst="rect">
+            <a:avLst/>
+          </a:prstGeom>
+          <a:noFill/>
+        </p:spPr>
+        <p:txBody>
+          <a:bodyPr wrap="square" anchor="t" lIns="0" rIns="0" tIns="0" bIns="0">
+            <a:spAutoFit/>
+          </a:bodyPr>
+          <a:lstStyle/>
+          <a:p>
+            <a:pPr algn="l">
+              <a:lnSpc>
+                <a:spcPct val="130000"/>
+              </a:lnSpc>
+            </a:pPr>
+            <a:r>
+              <a:rPr b="0" sz="1250">
+                <a:solidFill>
+                  <a:srgbClr val="898781"/>
+                </a:solidFill>
+                <a:latin typeface="Arial"/>
+              </a:rPr>
+              <a:t>O enunciado deixa em aberto como transformar notas de palavras numa decisão sobre o post. Estas foram as nossas escolhas, e o motivo de cada uma.</a:t>
+            </a:r>
+          </a:p>
+        </p:txBody>
+      </p:sp>
+      <p:sp>
+        <p:nvSpPr>
+          <p:cNvPr id="5" name="Rounded Rectangle 4"/>
+          <p:cNvSpPr/>
+          <p:nvPr/>
+        </p:nvSpPr>
+        <p:spPr>
+          <a:xfrm>
+            <a:off x="640080" y="1874519"/>
+            <a:ext cx="5349240" cy="1463040"/>
+          </a:xfrm>
+          <a:prstGeom prst="roundRect">
+            <a:avLst/>
+          </a:prstGeom>
+          <a:solidFill>
+            <a:srgbClr val="FFFFFF"/>
+          </a:solidFill>
+          <a:ln w="9525">
+            <a:solidFill>
+              <a:srgbClr val="E1E0D9"/>
+            </a:solidFill>
+          </a:ln>
+          <a:effectLst/>
+        </p:spPr>
+        <p:style>
+          <a:lnRef idx="1">
+            <a:schemeClr val="accent1"/>
+          </a:lnRef>
+          <a:fillRef idx="3">
+            <a:schemeClr val="accent1"/>
+          </a:fillRef>
+          <a:effectRef idx="2">
+            <a:schemeClr val="accent1"/>
+          </a:effectRef>
+          <a:fontRef idx="minor">
+            <a:schemeClr val="lt1"/>
+          </a:fontRef>
+        </p:style>
+        <p:txBody>
+          <a:bodyPr rtlCol="0" anchor="ctr"/>
+          <a:lstStyle/>
+          <a:p/>
+        </p:txBody>
+      </p:sp>
+      <p:sp>
+        <p:nvSpPr>
+          <p:cNvPr id="6" name="Rectangle 5"/>
+          <p:cNvSpPr/>
+          <p:nvPr/>
+        </p:nvSpPr>
+        <p:spPr>
+          <a:xfrm>
+            <a:off x="640080" y="1874519"/>
+            <a:ext cx="45720" cy="1463040"/>
+          </a:xfrm>
+          <a:prstGeom prst="rect">
+            <a:avLst/>
+          </a:prstGeom>
+          <a:solidFill>
+            <a:srgbClr val="0B0B0B"/>
+          </a:solidFill>
+          <a:ln>
+            <a:noFill/>
+          </a:ln>
+          <a:effectLst/>
+        </p:spPr>
+        <p:style>
+          <a:lnRef idx="1">
+            <a:schemeClr val="accent1"/>
+          </a:lnRef>
+          <a:fillRef idx="3">
+            <a:schemeClr val="accent1"/>
+          </a:fillRef>
+          <a:effectRef idx="2">
+            <a:schemeClr val="accent1"/>
+          </a:effectRef>
+          <a:fontRef idx="minor">
+            <a:schemeClr val="lt1"/>
+          </a:fontRef>
+        </p:style>
+        <p:txBody>
+          <a:bodyPr rtlCol="0" anchor="ctr"/>
+          <a:lstStyle/>
+          <a:p/>
+        </p:txBody>
+      </p:sp>
+      <p:sp>
+        <p:nvSpPr>
+          <p:cNvPr id="7" name="TextBox 6"/>
+          <p:cNvSpPr txBox="1"/>
+          <p:nvPr/>
+        </p:nvSpPr>
+        <p:spPr>
+          <a:xfrm>
+            <a:off x="914400" y="2057399"/>
+            <a:ext cx="4846320" cy="182880"/>
+          </a:xfrm>
+          <a:prstGeom prst="rect">
+            <a:avLst/>
+          </a:prstGeom>
+          <a:noFill/>
+        </p:spPr>
+        <p:txBody>
+          <a:bodyPr wrap="square" anchor="t" lIns="0" rIns="0" tIns="0" bIns="0">
+            <a:spAutoFit/>
+          </a:bodyPr>
+          <a:lstStyle/>
+          <a:p>
+            <a:pPr algn="l">
+              <a:lnSpc>
+                <a:spcPct val="125000"/>
+              </a:lnSpc>
+            </a:pPr>
+            <a:r>
+              <a:rPr b="1" sz="900">
+                <a:solidFill>
+                  <a:srgbClr val="898781"/>
+                </a:solidFill>
+                <a:latin typeface="Arial"/>
+              </a:rPr>
+              <a:t>ESCOLHA 1 · UMA ENTIDADE SÓ</a:t>
+            </a:r>
+          </a:p>
+        </p:txBody>
+      </p:sp>
+      <p:sp>
+        <p:nvSpPr>
+          <p:cNvPr id="8" name="TextBox 7"/>
+          <p:cNvSpPr txBox="1"/>
+          <p:nvPr/>
+        </p:nvSpPr>
+        <p:spPr>
+          <a:xfrm>
+            <a:off x="914400" y="2285999"/>
+            <a:ext cx="4846320" cy="228600"/>
+          </a:xfrm>
+          <a:prstGeom prst="rect">
+            <a:avLst/>
+          </a:prstGeom>
+          <a:noFill/>
+        </p:spPr>
+        <p:txBody>
+          <a:bodyPr wrap="square" anchor="t" lIns="0" rIns="0" tIns="0" bIns="0">
+            <a:spAutoFit/>
+          </a:bodyPr>
+          <a:lstStyle/>
+          <a:p>
+            <a:pPr algn="l">
+              <a:lnSpc>
+                <a:spcPct val="125000"/>
+              </a:lnSpc>
+            </a:pPr>
+            <a:r>
+              <a:rPr b="1" sz="1400">
+                <a:solidFill>
+                  <a:srgbClr val="0B0B0B"/>
+                </a:solidFill>
+                <a:latin typeface="Arial"/>
+              </a:rPr>
+              <a:t>Buscamos apenas “Argentina”</a:t>
+            </a:r>
+          </a:p>
+        </p:txBody>
+      </p:sp>
+      <p:sp>
+        <p:nvSpPr>
+          <p:cNvPr id="9" name="TextBox 8"/>
+          <p:cNvSpPr txBox="1"/>
+          <p:nvPr/>
+        </p:nvSpPr>
+        <p:spPr>
+          <a:xfrm>
+            <a:off x="914400" y="2560319"/>
+            <a:ext cx="4818888" cy="457200"/>
+          </a:xfrm>
+          <a:prstGeom prst="rect">
+            <a:avLst/>
+          </a:prstGeom>
+          <a:noFill/>
+        </p:spPr>
+        <p:txBody>
+          <a:bodyPr wrap="square" anchor="t" lIns="0" rIns="0" tIns="0" bIns="0">
+            <a:spAutoFit/>
+          </a:bodyPr>
+          <a:lstStyle/>
+          <a:p>
+            <a:pPr algn="l">
+              <a:lnSpc>
+                <a:spcPct val="128000"/>
+              </a:lnSpc>
+            </a:pPr>
+            <a:r>
+              <a:rPr b="0" sz="1100">
+                <a:solidFill>
+                  <a:srgbClr val="52514E"/>
+                </a:solidFill>
+                <a:latin typeface="Arial"/>
+              </a:rPr>
+              <a:t>Testamos buscar também Buenos Aires e Patagônia, para ter mais posts. Mas isso trazia turismo e natureza — </a:t>
+            </a:r>
+            <a:r>
+              <a:rPr b="1" sz="1100">
+                <a:solidFill>
+                  <a:srgbClr val="0B0B0B"/>
+                </a:solidFill>
+                <a:latin typeface="Arial"/>
+              </a:rPr>
+              <a:t>outras entidades</a:t>
+            </a:r>
+            <a:r>
+              <a:rPr b="0" sz="1100">
+                <a:solidFill>
+                  <a:srgbClr val="52514E"/>
+                </a:solidFill>
+                <a:latin typeface="Arial"/>
+              </a:rPr>
+              <a:t> — e empurrava o resultado para o positivo.</a:t>
+            </a:r>
+          </a:p>
+        </p:txBody>
+      </p:sp>
+      <p:sp>
+        <p:nvSpPr>
+          <p:cNvPr id="10" name="Rounded Rectangle 9"/>
+          <p:cNvSpPr/>
+          <p:nvPr/>
+        </p:nvSpPr>
+        <p:spPr>
+          <a:xfrm>
+            <a:off x="640080" y="3502151"/>
+            <a:ext cx="5349240" cy="2377440"/>
+          </a:xfrm>
+          <a:prstGeom prst="roundRect">
+            <a:avLst/>
+          </a:prstGeom>
+          <a:solidFill>
+            <a:srgbClr val="FFFFFF"/>
+          </a:solidFill>
+          <a:ln w="9525">
+            <a:solidFill>
+              <a:srgbClr val="E1E0D9"/>
+            </a:solidFill>
+          </a:ln>
+          <a:effectLst/>
+        </p:spPr>
+        <p:style>
+          <a:lnRef idx="1">
+            <a:schemeClr val="accent1"/>
+          </a:lnRef>
+          <a:fillRef idx="3">
+            <a:schemeClr val="accent1"/>
+          </a:fillRef>
+          <a:effectRef idx="2">
+            <a:schemeClr val="accent1"/>
+          </a:effectRef>
+          <a:fontRef idx="minor">
+            <a:schemeClr val="lt1"/>
+          </a:fontRef>
+        </p:style>
+        <p:txBody>
+          <a:bodyPr rtlCol="0" anchor="ctr"/>
+          <a:lstStyle/>
+          <a:p/>
+        </p:txBody>
+      </p:sp>
+      <p:sp>
+        <p:nvSpPr>
+          <p:cNvPr id="11" name="Rectangle 10"/>
+          <p:cNvSpPr/>
+          <p:nvPr/>
+        </p:nvSpPr>
+        <p:spPr>
+          <a:xfrm>
+            <a:off x="640080" y="3502151"/>
+            <a:ext cx="45720" cy="2377440"/>
+          </a:xfrm>
+          <a:prstGeom prst="rect">
+            <a:avLst/>
+          </a:prstGeom>
+          <a:solidFill>
+            <a:srgbClr val="0B0B0B"/>
+          </a:solidFill>
+          <a:ln>
+            <a:noFill/>
+          </a:ln>
+          <a:effectLst/>
+        </p:spPr>
+        <p:style>
+          <a:lnRef idx="1">
+            <a:schemeClr val="accent1"/>
+          </a:lnRef>
+          <a:fillRef idx="3">
+            <a:schemeClr val="accent1"/>
+          </a:fillRef>
+          <a:effectRef idx="2">
+            <a:schemeClr val="accent1"/>
+          </a:effectRef>
+          <a:fontRef idx="minor">
+            <a:schemeClr val="lt1"/>
+          </a:fontRef>
+        </p:style>
+        <p:txBody>
+          <a:bodyPr rtlCol="0" anchor="ctr"/>
+          <a:lstStyle/>
+          <a:p/>
+        </p:txBody>
+      </p:sp>
+      <p:sp>
+        <p:nvSpPr>
+          <p:cNvPr id="12" name="TextBox 11"/>
+          <p:cNvSpPr txBox="1"/>
+          <p:nvPr/>
+        </p:nvSpPr>
+        <p:spPr>
+          <a:xfrm>
+            <a:off x="914400" y="3685031"/>
+            <a:ext cx="4846320" cy="182880"/>
+          </a:xfrm>
+          <a:prstGeom prst="rect">
+            <a:avLst/>
+          </a:prstGeom>
+          <a:noFill/>
+        </p:spPr>
+        <p:txBody>
+          <a:bodyPr wrap="square" anchor="t" lIns="0" rIns="0" tIns="0" bIns="0">
+            <a:spAutoFit/>
+          </a:bodyPr>
+          <a:lstStyle/>
+          <a:p>
+            <a:pPr algn="l">
+              <a:lnSpc>
+                <a:spcPct val="125000"/>
+              </a:lnSpc>
+            </a:pPr>
+            <a:r>
+              <a:rPr b="1" sz="900">
+                <a:solidFill>
+                  <a:srgbClr val="898781"/>
+                </a:solidFill>
+                <a:latin typeface="Arial"/>
+              </a:rPr>
+              <a:t>ESCOLHA 2 · O PONTO DE CORTE</a:t>
+            </a:r>
+          </a:p>
+        </p:txBody>
+      </p:sp>
+      <p:sp>
+        <p:nvSpPr>
+          <p:cNvPr id="13" name="TextBox 12"/>
+          <p:cNvSpPr txBox="1"/>
+          <p:nvPr/>
+        </p:nvSpPr>
+        <p:spPr>
+          <a:xfrm>
+            <a:off x="914400" y="3913631"/>
+            <a:ext cx="4846320" cy="228600"/>
+          </a:xfrm>
+          <a:prstGeom prst="rect">
+            <a:avLst/>
+          </a:prstGeom>
+          <a:noFill/>
+        </p:spPr>
+        <p:txBody>
+          <a:bodyPr wrap="square" anchor="t" lIns="0" rIns="0" tIns="0" bIns="0">
+            <a:spAutoFit/>
+          </a:bodyPr>
+          <a:lstStyle/>
+          <a:p>
+            <a:pPr algn="l">
+              <a:lnSpc>
+                <a:spcPct val="125000"/>
+              </a:lnSpc>
+            </a:pPr>
+            <a:r>
+              <a:rPr b="1" sz="1400">
+                <a:solidFill>
+                  <a:srgbClr val="0B0B0B"/>
+                </a:solidFill>
+                <a:latin typeface="Arial"/>
+              </a:rPr>
+              <a:t>Comparamos com 58, não com 50</a:t>
+            </a:r>
+          </a:p>
+        </p:txBody>
+      </p:sp>
+      <p:sp>
+        <p:nvSpPr>
+          <p:cNvPr id="14" name="TextBox 13"/>
+          <p:cNvSpPr txBox="1"/>
+          <p:nvPr/>
+        </p:nvSpPr>
+        <p:spPr>
+          <a:xfrm>
+            <a:off x="914400" y="4187951"/>
+            <a:ext cx="4818888" cy="457200"/>
+          </a:xfrm>
+          <a:prstGeom prst="rect">
+            <a:avLst/>
+          </a:prstGeom>
+          <a:noFill/>
+        </p:spPr>
+        <p:txBody>
+          <a:bodyPr wrap="square" anchor="t" lIns="0" rIns="0" tIns="0" bIns="0">
+            <a:spAutoFit/>
+          </a:bodyPr>
+          <a:lstStyle/>
+          <a:p>
+            <a:pPr algn="l">
+              <a:lnSpc>
+                <a:spcPct val="128000"/>
+              </a:lnSpc>
+            </a:pPr>
+            <a:r>
+              <a:rPr b="0" sz="1100">
+                <a:solidFill>
+                  <a:srgbClr val="52514E"/>
+                </a:solidFill>
+                <a:latin typeface="Arial"/>
+              </a:rPr>
+              <a:t>A escala vai de 0 a 100, então o meio </a:t>
+            </a:r>
+            <a:r>
+              <a:rPr i="1" sz="1100">
+                <a:solidFill>
+                  <a:srgbClr val="52514E"/>
+                </a:solidFill>
+                <a:latin typeface="Arial"/>
+              </a:rPr>
+              <a:t>parece</a:t>
+            </a:r>
+            <a:r>
+              <a:rPr b="0" sz="1100">
+                <a:solidFill>
+                  <a:srgbClr val="52514E"/>
+                </a:solidFill>
+                <a:latin typeface="Arial"/>
+              </a:rPr>
+              <a:t> ser 50. Mas o ANEW não é equilibrado: </a:t>
+            </a:r>
+            <a:r>
+              <a:rPr b="1" sz="1100">
+                <a:solidFill>
+                  <a:srgbClr val="0B0B0B"/>
+                </a:solidFill>
+                <a:latin typeface="Arial"/>
+              </a:rPr>
+              <a:t>62% das suas palavras estão acima de 50</a:t>
+            </a:r>
+            <a:r>
+              <a:rPr b="0" sz="1100">
+                <a:solidFill>
+                  <a:srgbClr val="52514E"/>
+                </a:solidFill>
+                <a:latin typeface="Arial"/>
+              </a:rPr>
+              <a:t>, e a média delas é 58.</a:t>
+            </a:r>
+          </a:p>
+        </p:txBody>
+      </p:sp>
+      <p:sp>
+        <p:nvSpPr>
+          <p:cNvPr id="15" name="TextBox 14"/>
+          <p:cNvSpPr txBox="1"/>
+          <p:nvPr/>
+        </p:nvSpPr>
+        <p:spPr>
+          <a:xfrm>
+            <a:off x="914400" y="4800599"/>
+            <a:ext cx="4800600" cy="164592"/>
+          </a:xfrm>
+          <a:prstGeom prst="rect">
+            <a:avLst/>
+          </a:prstGeom>
+          <a:noFill/>
+        </p:spPr>
+        <p:txBody>
+          <a:bodyPr wrap="square" anchor="t" lIns="0" rIns="0" tIns="0" bIns="0">
+            <a:spAutoFit/>
+          </a:bodyPr>
+          <a:lstStyle/>
+          <a:p>
+            <a:pPr algn="l">
+              <a:lnSpc>
+                <a:spcPct val="125000"/>
+              </a:lnSpc>
+            </a:pPr>
+            <a:r>
+              <a:rPr b="0" sz="900">
+                <a:solidFill>
+                  <a:srgbClr val="898781"/>
+                </a:solidFill>
+                <a:latin typeface="Arial"/>
+              </a:rPr>
+              <a:t>os mesmos posts, cortando em 50</a:t>
+            </a:r>
+          </a:p>
+        </p:txBody>
+      </p:sp>
+      <p:sp>
+        <p:nvSpPr>
+          <p:cNvPr id="16" name="Rectangle 15"/>
+          <p:cNvSpPr/>
+          <p:nvPr/>
+        </p:nvSpPr>
+        <p:spPr>
+          <a:xfrm>
+            <a:off x="914400" y="4983479"/>
+            <a:ext cx="192024" cy="237744"/>
+          </a:xfrm>
+          <a:prstGeom prst="rect">
+            <a:avLst/>
+          </a:prstGeom>
+          <a:solidFill>
+            <a:srgbClr val="E34948"/>
+          </a:solidFill>
+          <a:ln>
+            <a:noFill/>
+          </a:ln>
+          <a:effectLst/>
+        </p:spPr>
+        <p:style>
+          <a:lnRef idx="1">
+            <a:schemeClr val="accent1"/>
+          </a:lnRef>
+          <a:fillRef idx="3">
+            <a:schemeClr val="accent1"/>
+          </a:fillRef>
+          <a:effectRef idx="2">
+            <a:schemeClr val="accent1"/>
+          </a:effectRef>
+          <a:fontRef idx="minor">
+            <a:schemeClr val="lt1"/>
+          </a:fontRef>
+        </p:style>
+        <p:txBody>
+          <a:bodyPr rtlCol="0" anchor="ctr"/>
+          <a:lstStyle/>
+          <a:p/>
+        </p:txBody>
+      </p:sp>
+      <p:sp>
+        <p:nvSpPr>
+          <p:cNvPr id="17" name="Rectangle 16"/>
+          <p:cNvSpPr/>
+          <p:nvPr/>
+        </p:nvSpPr>
+        <p:spPr>
+          <a:xfrm>
+            <a:off x="1106424" y="4983479"/>
+            <a:ext cx="4608576" cy="237744"/>
+          </a:xfrm>
+          <a:prstGeom prst="rect">
+            <a:avLst/>
+          </a:prstGeom>
+          <a:solidFill>
+            <a:srgbClr val="3987E5"/>
+          </a:solidFill>
+          <a:ln>
+            <a:noFill/>
+          </a:ln>
+          <a:effectLst/>
+        </p:spPr>
+        <p:style>
+          <a:lnRef idx="1">
+            <a:schemeClr val="accent1"/>
+          </a:lnRef>
+          <a:fillRef idx="3">
+            <a:schemeClr val="accent1"/>
+          </a:fillRef>
+          <a:effectRef idx="2">
+            <a:schemeClr val="accent1"/>
+          </a:effectRef>
+          <a:fontRef idx="minor">
+            <a:schemeClr val="lt1"/>
+          </a:fontRef>
+        </p:style>
+        <p:txBody>
+          <a:bodyPr rtlCol="0" anchor="ctr" lIns="0" rIns="0"/>
+          <a:lstStyle/>
+          <a:p>
+            <a:pPr algn="ctr"/>
+            <a:r>
+              <a:rPr sz="1000" b="1">
+                <a:solidFill>
+                  <a:srgbClr val="FFFFFF"/>
+                </a:solidFill>
+                <a:latin typeface="Arial"/>
+              </a:rPr>
+              <a:t>96% positivo</a:t>
+            </a:r>
+          </a:p>
+        </p:txBody>
+      </p:sp>
+      <p:sp>
+        <p:nvSpPr>
+          <p:cNvPr id="18" name="TextBox 17"/>
+          <p:cNvSpPr txBox="1"/>
+          <p:nvPr/>
+        </p:nvSpPr>
+        <p:spPr>
+          <a:xfrm>
+            <a:off x="914400" y="5330951"/>
+            <a:ext cx="4800600" cy="164592"/>
+          </a:xfrm>
+          <a:prstGeom prst="rect">
+            <a:avLst/>
+          </a:prstGeom>
+          <a:noFill/>
+        </p:spPr>
+        <p:txBody>
+          <a:bodyPr wrap="square" anchor="t" lIns="0" rIns="0" tIns="0" bIns="0">
+            <a:spAutoFit/>
+          </a:bodyPr>
+          <a:lstStyle/>
+          <a:p>
+            <a:pPr algn="l">
+              <a:lnSpc>
+                <a:spcPct val="125000"/>
+              </a:lnSpc>
+            </a:pPr>
+            <a:r>
+              <a:rPr b="0" sz="900">
+                <a:solidFill>
+                  <a:srgbClr val="898781"/>
+                </a:solidFill>
+                <a:latin typeface="Arial"/>
+              </a:rPr>
+              <a:t>cortando em 58, a média real do dicionário</a:t>
+            </a:r>
+          </a:p>
+        </p:txBody>
+      </p:sp>
+      <p:sp>
+        <p:nvSpPr>
+          <p:cNvPr id="19" name="Rectangle 18"/>
+          <p:cNvSpPr/>
+          <p:nvPr/>
+        </p:nvSpPr>
+        <p:spPr>
+          <a:xfrm>
+            <a:off x="914400" y="5513831"/>
+            <a:ext cx="144018" cy="237744"/>
+          </a:xfrm>
+          <a:prstGeom prst="rect">
+            <a:avLst/>
+          </a:prstGeom>
+          <a:solidFill>
+            <a:srgbClr val="E34948"/>
+          </a:solidFill>
+          <a:ln>
+            <a:noFill/>
+          </a:ln>
+          <a:effectLst/>
+        </p:spPr>
+        <p:style>
+          <a:lnRef idx="1">
+            <a:schemeClr val="accent1"/>
+          </a:lnRef>
+          <a:fillRef idx="3">
+            <a:schemeClr val="accent1"/>
+          </a:fillRef>
+          <a:effectRef idx="2">
+            <a:schemeClr val="accent1"/>
+          </a:effectRef>
+          <a:fontRef idx="minor">
+            <a:schemeClr val="lt1"/>
+          </a:fontRef>
+        </p:style>
+        <p:txBody>
+          <a:bodyPr rtlCol="0" anchor="ctr"/>
+          <a:lstStyle/>
+          <a:p/>
+        </p:txBody>
+      </p:sp>
+      <p:sp>
+        <p:nvSpPr>
+          <p:cNvPr id="20" name="Rectangle 19"/>
+          <p:cNvSpPr/>
+          <p:nvPr/>
+        </p:nvSpPr>
+        <p:spPr>
+          <a:xfrm>
+            <a:off x="1058418" y="5513831"/>
+            <a:ext cx="1968246" cy="237744"/>
+          </a:xfrm>
+          <a:prstGeom prst="rect">
+            <a:avLst/>
+          </a:prstGeom>
+          <a:solidFill>
+            <a:srgbClr val="898781"/>
+          </a:solidFill>
+          <a:ln>
+            <a:noFill/>
+          </a:ln>
+          <a:effectLst/>
+        </p:spPr>
+        <p:style>
+          <a:lnRef idx="1">
+            <a:schemeClr val="accent1"/>
+          </a:lnRef>
+          <a:fillRef idx="3">
+            <a:schemeClr val="accent1"/>
+          </a:fillRef>
+          <a:effectRef idx="2">
+            <a:schemeClr val="accent1"/>
+          </a:effectRef>
+          <a:fontRef idx="minor">
+            <a:schemeClr val="lt1"/>
+          </a:fontRef>
+        </p:style>
+        <p:txBody>
+          <a:bodyPr rtlCol="0" anchor="ctr" lIns="0" rIns="0"/>
+          <a:lstStyle/>
+          <a:p>
+            <a:pPr algn="ctr"/>
+            <a:r>
+              <a:rPr sz="1000" b="1">
+                <a:solidFill>
+                  <a:srgbClr val="FFFFFF"/>
+                </a:solidFill>
+                <a:latin typeface="Arial"/>
+              </a:rPr>
+              <a:t>41% neutro</a:t>
+            </a:r>
+          </a:p>
+        </p:txBody>
+      </p:sp>
+      <p:sp>
+        <p:nvSpPr>
+          <p:cNvPr id="21" name="Rectangle 20"/>
+          <p:cNvSpPr/>
+          <p:nvPr/>
+        </p:nvSpPr>
+        <p:spPr>
+          <a:xfrm>
+            <a:off x="3026664" y="5513831"/>
+            <a:ext cx="2688336" cy="237744"/>
+          </a:xfrm>
+          <a:prstGeom prst="rect">
+            <a:avLst/>
+          </a:prstGeom>
+          <a:solidFill>
+            <a:srgbClr val="3987E5"/>
+          </a:solidFill>
+          <a:ln>
+            <a:noFill/>
+          </a:ln>
+          <a:effectLst/>
+        </p:spPr>
+        <p:style>
+          <a:lnRef idx="1">
+            <a:schemeClr val="accent1"/>
+          </a:lnRef>
+          <a:fillRef idx="3">
+            <a:schemeClr val="accent1"/>
+          </a:fillRef>
+          <a:effectRef idx="2">
+            <a:schemeClr val="accent1"/>
+          </a:effectRef>
+          <a:fontRef idx="minor">
+            <a:schemeClr val="lt1"/>
+          </a:fontRef>
+        </p:style>
+        <p:txBody>
+          <a:bodyPr rtlCol="0" anchor="ctr" lIns="0" rIns="0"/>
+          <a:lstStyle/>
+          <a:p>
+            <a:pPr algn="ctr"/>
+            <a:r>
+              <a:rPr sz="1000" b="1">
+                <a:solidFill>
+                  <a:srgbClr val="FFFFFF"/>
+                </a:solidFill>
+                <a:latin typeface="Arial"/>
+              </a:rPr>
+              <a:t>56% positivo</a:t>
+            </a:r>
+          </a:p>
+        </p:txBody>
+      </p:sp>
+      <p:sp>
+        <p:nvSpPr>
+          <p:cNvPr id="22" name="Rounded Rectangle 21"/>
+          <p:cNvSpPr/>
+          <p:nvPr/>
+        </p:nvSpPr>
+        <p:spPr>
+          <a:xfrm>
+            <a:off x="6583680" y="1874519"/>
+            <a:ext cx="4983480" cy="960120"/>
+          </a:xfrm>
+          <a:prstGeom prst="roundRect">
+            <a:avLst/>
+          </a:prstGeom>
+          <a:solidFill>
+            <a:srgbClr val="FFFFFF"/>
+          </a:solidFill>
+          <a:ln w="9525">
+            <a:solidFill>
+              <a:srgbClr val="E1E0D9"/>
+            </a:solidFill>
+          </a:ln>
+          <a:effectLst/>
+        </p:spPr>
+        <p:style>
+          <a:lnRef idx="1">
+            <a:schemeClr val="accent1"/>
+          </a:lnRef>
+          <a:fillRef idx="3">
+            <a:schemeClr val="accent1"/>
+          </a:fillRef>
+          <a:effectRef idx="2">
+            <a:schemeClr val="accent1"/>
+          </a:effectRef>
+          <a:fontRef idx="minor">
+            <a:schemeClr val="lt1"/>
+          </a:fontRef>
+        </p:style>
+        <p:txBody>
+          <a:bodyPr rtlCol="0" anchor="ctr"/>
+          <a:lstStyle/>
+          <a:p/>
+        </p:txBody>
+      </p:sp>
+      <p:sp>
+        <p:nvSpPr>
+          <p:cNvPr id="23" name="Rectangle 22"/>
+          <p:cNvSpPr/>
+          <p:nvPr/>
+        </p:nvSpPr>
+        <p:spPr>
+          <a:xfrm>
+            <a:off x="6583680" y="1874519"/>
+            <a:ext cx="45720" cy="960120"/>
+          </a:xfrm>
+          <a:prstGeom prst="rect">
+            <a:avLst/>
+          </a:prstGeom>
+          <a:solidFill>
+            <a:srgbClr val="0B0B0B"/>
+          </a:solidFill>
+          <a:ln>
+            <a:noFill/>
+          </a:ln>
+          <a:effectLst/>
+        </p:spPr>
+        <p:style>
+          <a:lnRef idx="1">
+            <a:schemeClr val="accent1"/>
+          </a:lnRef>
+          <a:fillRef idx="3">
+            <a:schemeClr val="accent1"/>
+          </a:fillRef>
+          <a:effectRef idx="2">
+            <a:schemeClr val="accent1"/>
+          </a:effectRef>
+          <a:fontRef idx="minor">
+            <a:schemeClr val="lt1"/>
+          </a:fontRef>
+        </p:style>
+        <p:txBody>
+          <a:bodyPr rtlCol="0" anchor="ctr"/>
+          <a:lstStyle/>
+          <a:p/>
+        </p:txBody>
+      </p:sp>
+      <p:sp>
+        <p:nvSpPr>
+          <p:cNvPr id="24" name="TextBox 23"/>
+          <p:cNvSpPr txBox="1"/>
+          <p:nvPr/>
+        </p:nvSpPr>
+        <p:spPr>
+          <a:xfrm>
+            <a:off x="6858000" y="2039111"/>
+            <a:ext cx="4480560" cy="182880"/>
+          </a:xfrm>
+          <a:prstGeom prst="rect">
+            <a:avLst/>
+          </a:prstGeom>
+          <a:noFill/>
+        </p:spPr>
+        <p:txBody>
+          <a:bodyPr wrap="square" anchor="t" lIns="0" rIns="0" tIns="0" bIns="0">
+            <a:spAutoFit/>
+          </a:bodyPr>
+          <a:lstStyle/>
+          <a:p>
+            <a:pPr algn="l">
+              <a:lnSpc>
+                <a:spcPct val="125000"/>
+              </a:lnSpc>
+            </a:pPr>
+            <a:r>
+              <a:rPr b="1" sz="900">
+                <a:solidFill>
+                  <a:srgbClr val="898781"/>
+                </a:solidFill>
+                <a:latin typeface="Arial"/>
+              </a:rPr>
+              <a:t>ESCOLHA 3 · QUANDO NÃO OPINAR</a:t>
+            </a:r>
+          </a:p>
+        </p:txBody>
+      </p:sp>
+      <p:sp>
+        <p:nvSpPr>
+          <p:cNvPr id="25" name="TextBox 24"/>
+          <p:cNvSpPr txBox="1"/>
+          <p:nvPr/>
+        </p:nvSpPr>
+        <p:spPr>
+          <a:xfrm>
+            <a:off x="6858000" y="2258567"/>
+            <a:ext cx="4453128" cy="457200"/>
+          </a:xfrm>
+          <a:prstGeom prst="rect">
+            <a:avLst/>
+          </a:prstGeom>
+          <a:noFill/>
+        </p:spPr>
+        <p:txBody>
+          <a:bodyPr wrap="square" anchor="t" lIns="0" rIns="0" tIns="0" bIns="0">
+            <a:spAutoFit/>
+          </a:bodyPr>
+          <a:lstStyle/>
+          <a:p>
+            <a:pPr algn="l">
+              <a:lnSpc>
+                <a:spcPct val="115000"/>
+              </a:lnSpc>
+            </a:pPr>
+            <a:r>
+              <a:rPr b="1" sz="1400">
+                <a:solidFill>
+                  <a:srgbClr val="0B0B0B"/>
+                </a:solidFill>
+                <a:latin typeface="Arial"/>
+              </a:rPr>
+              <a:t>Post com menos de 3 palavras conhecidas é descartado</a:t>
+            </a:r>
+          </a:p>
+        </p:txBody>
+      </p:sp>
+      <p:sp>
+        <p:nvSpPr>
+          <p:cNvPr id="26" name="Rounded Rectangle 25"/>
+          <p:cNvSpPr/>
+          <p:nvPr/>
+        </p:nvSpPr>
+        <p:spPr>
+          <a:xfrm>
+            <a:off x="6583680" y="3017519"/>
+            <a:ext cx="4983480" cy="2697480"/>
+          </a:xfrm>
+          <a:prstGeom prst="roundRect">
+            <a:avLst/>
+          </a:prstGeom>
+          <a:solidFill>
+            <a:srgbClr val="FFFFFF"/>
+          </a:solidFill>
+          <a:ln w="9525">
+            <a:solidFill>
+              <a:srgbClr val="E1E0D9"/>
+            </a:solidFill>
+          </a:ln>
+          <a:effectLst/>
+        </p:spPr>
+        <p:style>
+          <a:lnRef idx="1">
+            <a:schemeClr val="accent1"/>
+          </a:lnRef>
+          <a:fillRef idx="3">
+            <a:schemeClr val="accent1"/>
+          </a:fillRef>
+          <a:effectRef idx="2">
+            <a:schemeClr val="accent1"/>
+          </a:effectRef>
+          <a:fontRef idx="minor">
+            <a:schemeClr val="lt1"/>
+          </a:fontRef>
+        </p:style>
+        <p:txBody>
+          <a:bodyPr rtlCol="0" anchor="ctr"/>
+          <a:lstStyle/>
+          <a:p/>
+        </p:txBody>
+      </p:sp>
+      <p:sp>
+        <p:nvSpPr>
+          <p:cNvPr id="27" name="TextBox 26"/>
+          <p:cNvSpPr txBox="1"/>
+          <p:nvPr/>
+        </p:nvSpPr>
+        <p:spPr>
+          <a:xfrm>
+            <a:off x="6839712" y="3200399"/>
+            <a:ext cx="4480560" cy="182880"/>
+          </a:xfrm>
+          <a:prstGeom prst="rect">
+            <a:avLst/>
+          </a:prstGeom>
+          <a:noFill/>
+        </p:spPr>
+        <p:txBody>
+          <a:bodyPr wrap="square" anchor="t" lIns="0" rIns="0" tIns="0" bIns="0">
+            <a:spAutoFit/>
+          </a:bodyPr>
+          <a:lstStyle/>
+          <a:p>
+            <a:pPr algn="l">
+              <a:lnSpc>
+                <a:spcPct val="125000"/>
+              </a:lnSpc>
+            </a:pPr>
+            <a:r>
+              <a:rPr b="1" sz="900">
+                <a:solidFill>
+                  <a:srgbClr val="898781"/>
+                </a:solidFill>
+                <a:latin typeface="Arial"/>
+              </a:rPr>
+              <a:t>POST REAL · O ANEW SÓ RECONHECEU UMA PALAVRA</a:t>
+            </a:r>
+          </a:p>
+        </p:txBody>
+      </p:sp>
+      <p:sp>
+        <p:nvSpPr>
+          <p:cNvPr id="28" name="TextBox 27"/>
+          <p:cNvSpPr txBox="1"/>
+          <p:nvPr/>
+        </p:nvSpPr>
+        <p:spPr>
+          <a:xfrm>
+            <a:off x="6839712" y="3456431"/>
+            <a:ext cx="4471416" cy="868680"/>
+          </a:xfrm>
+          <a:prstGeom prst="rect">
+            <a:avLst/>
+          </a:prstGeom>
+          <a:noFill/>
+        </p:spPr>
+        <p:txBody>
+          <a:bodyPr wrap="square" anchor="t" lIns="0" rIns="0" tIns="0" bIns="0">
+            <a:spAutoFit/>
+          </a:bodyPr>
+          <a:lstStyle/>
+          <a:p>
+            <a:pPr algn="l">
+              <a:lnSpc>
+                <a:spcPct val="132000"/>
+              </a:lnSpc>
+            </a:pPr>
+            <a:r>
+              <a:rPr i="1" sz="1100">
+                <a:solidFill>
+                  <a:srgbClr val="0B0B0B"/>
+                </a:solidFill>
+                <a:latin typeface="Arial"/>
+              </a:rPr>
+              <a:t>“An elderly lady of the indigenous Humahuaca community in Jujuy cries as the puppet regime in Argentina evicts her from her </a:t>
+            </a:r>
+            <a:r>
+              <a:rPr b="1" sz="1100">
+                <a:solidFill>
+                  <a:srgbClr val="0B0B0B"/>
+                </a:solidFill>
+                <a:latin typeface="Arial"/>
+              </a:rPr>
+              <a:t>home · 90</a:t>
+            </a:r>
+            <a:r>
+              <a:rPr i="1" sz="1100">
+                <a:solidFill>
+                  <a:srgbClr val="0B0B0B"/>
+                </a:solidFill>
+                <a:latin typeface="Arial"/>
+              </a:rPr>
+              <a:t> and land. Large-scale protests against the law continue.”</a:t>
+            </a:r>
+          </a:p>
+        </p:txBody>
+      </p:sp>
+      <p:sp>
+        <p:nvSpPr>
+          <p:cNvPr id="29" name="Rounded Rectangle 28"/>
+          <p:cNvSpPr/>
+          <p:nvPr/>
+        </p:nvSpPr>
+        <p:spPr>
+          <a:xfrm>
+            <a:off x="6839712" y="4498847"/>
+            <a:ext cx="2199132" cy="658368"/>
+          </a:xfrm>
+          <a:prstGeom prst="roundRect">
+            <a:avLst/>
+          </a:prstGeom>
+          <a:solidFill>
+            <a:srgbClr val="FDEEEE"/>
+          </a:solidFill>
+          <a:ln w="9525">
+            <a:solidFill>
+              <a:srgbClr val="E34948"/>
+            </a:solidFill>
+          </a:ln>
+          <a:effectLst/>
+        </p:spPr>
+        <p:style>
+          <a:lnRef idx="1">
+            <a:schemeClr val="accent1"/>
+          </a:lnRef>
+          <a:fillRef idx="3">
+            <a:schemeClr val="accent1"/>
+          </a:fillRef>
+          <a:effectRef idx="2">
+            <a:schemeClr val="accent1"/>
+          </a:effectRef>
+          <a:fontRef idx="minor">
+            <a:schemeClr val="lt1"/>
+          </a:fontRef>
+        </p:style>
+        <p:txBody>
+          <a:bodyPr rtlCol="0" anchor="ctr"/>
+          <a:lstStyle/>
+          <a:p/>
+        </p:txBody>
+      </p:sp>
+      <p:sp>
+        <p:nvSpPr>
+          <p:cNvPr id="30" name="TextBox 29"/>
+          <p:cNvSpPr txBox="1"/>
+          <p:nvPr/>
+        </p:nvSpPr>
+        <p:spPr>
+          <a:xfrm>
+            <a:off x="6967728" y="4590287"/>
+            <a:ext cx="1943100" cy="182880"/>
+          </a:xfrm>
+          <a:prstGeom prst="rect">
+            <a:avLst/>
+          </a:prstGeom>
+          <a:noFill/>
+        </p:spPr>
+        <p:txBody>
+          <a:bodyPr wrap="square" anchor="t" lIns="0" rIns="0" tIns="0" bIns="0">
+            <a:spAutoFit/>
+          </a:bodyPr>
+          <a:lstStyle/>
+          <a:p>
+            <a:pPr algn="l">
+              <a:lnSpc>
+                <a:spcPct val="125000"/>
+              </a:lnSpc>
+            </a:pPr>
+            <a:r>
+              <a:rPr b="0" sz="950">
+                <a:solidFill>
+                  <a:srgbClr val="52514E"/>
+                </a:solidFill>
+                <a:latin typeface="Arial"/>
+              </a:rPr>
+              <a:t>sem regra nenhuma:</a:t>
+            </a:r>
+          </a:p>
+        </p:txBody>
+      </p:sp>
+      <p:sp>
+        <p:nvSpPr>
+          <p:cNvPr id="31" name="TextBox 30"/>
+          <p:cNvSpPr txBox="1"/>
+          <p:nvPr/>
+        </p:nvSpPr>
+        <p:spPr>
+          <a:xfrm>
+            <a:off x="6967728" y="4800599"/>
+            <a:ext cx="1943100" cy="256032"/>
+          </a:xfrm>
+          <a:prstGeom prst="rect">
+            <a:avLst/>
+          </a:prstGeom>
+          <a:noFill/>
+        </p:spPr>
+        <p:txBody>
+          <a:bodyPr wrap="square" anchor="t" lIns="0" rIns="0" tIns="0" bIns="0">
+            <a:spAutoFit/>
+          </a:bodyPr>
+          <a:lstStyle/>
+          <a:p>
+            <a:pPr algn="l">
+              <a:lnSpc>
+                <a:spcPct val="125000"/>
+              </a:lnSpc>
+            </a:pPr>
+            <a:r>
+              <a:rPr b="1" sz="1400">
+                <a:solidFill>
+                  <a:srgbClr val="E34948"/>
+                </a:solidFill>
+                <a:latin typeface="Arial"/>
+              </a:rPr>
+              <a:t>POSITIVO · 90</a:t>
+            </a:r>
+          </a:p>
+        </p:txBody>
+      </p:sp>
+      <p:sp>
+        <p:nvSpPr>
+          <p:cNvPr id="32" name="Rounded Rectangle 31"/>
+          <p:cNvSpPr/>
+          <p:nvPr/>
+        </p:nvSpPr>
+        <p:spPr>
+          <a:xfrm>
+            <a:off x="9203436" y="4498847"/>
+            <a:ext cx="2199132" cy="658368"/>
+          </a:xfrm>
+          <a:prstGeom prst="roundRect">
+            <a:avLst/>
+          </a:prstGeom>
+          <a:solidFill>
+            <a:srgbClr val="EEF4FD"/>
+          </a:solidFill>
+          <a:ln w="9525">
+            <a:solidFill>
+              <a:srgbClr val="3987E5"/>
+            </a:solidFill>
+          </a:ln>
+          <a:effectLst/>
+        </p:spPr>
+        <p:style>
+          <a:lnRef idx="1">
+            <a:schemeClr val="accent1"/>
+          </a:lnRef>
+          <a:fillRef idx="3">
+            <a:schemeClr val="accent1"/>
+          </a:fillRef>
+          <a:effectRef idx="2">
+            <a:schemeClr val="accent1"/>
+          </a:effectRef>
+          <a:fontRef idx="minor">
+            <a:schemeClr val="lt1"/>
+          </a:fontRef>
+        </p:style>
+        <p:txBody>
+          <a:bodyPr rtlCol="0" anchor="ctr"/>
+          <a:lstStyle/>
+          <a:p/>
+        </p:txBody>
+      </p:sp>
+      <p:sp>
+        <p:nvSpPr>
+          <p:cNvPr id="33" name="TextBox 32"/>
+          <p:cNvSpPr txBox="1"/>
+          <p:nvPr/>
+        </p:nvSpPr>
+        <p:spPr>
+          <a:xfrm>
+            <a:off x="9331452" y="4590287"/>
+            <a:ext cx="1943100" cy="182880"/>
+          </a:xfrm>
+          <a:prstGeom prst="rect">
+            <a:avLst/>
+          </a:prstGeom>
+          <a:noFill/>
+        </p:spPr>
+        <p:txBody>
+          <a:bodyPr wrap="square" anchor="t" lIns="0" rIns="0" tIns="0" bIns="0">
+            <a:spAutoFit/>
+          </a:bodyPr>
+          <a:lstStyle/>
+          <a:p>
+            <a:pPr algn="l">
+              <a:lnSpc>
+                <a:spcPct val="125000"/>
+              </a:lnSpc>
+            </a:pPr>
+            <a:r>
+              <a:rPr b="0" sz="950">
+                <a:solidFill>
+                  <a:srgbClr val="52514E"/>
+                </a:solidFill>
+                <a:latin typeface="Arial"/>
+              </a:rPr>
+              <a:t>com a nossa regra:</a:t>
+            </a:r>
+          </a:p>
+        </p:txBody>
+      </p:sp>
+      <p:sp>
+        <p:nvSpPr>
+          <p:cNvPr id="34" name="TextBox 33"/>
+          <p:cNvSpPr txBox="1"/>
+          <p:nvPr/>
+        </p:nvSpPr>
+        <p:spPr>
+          <a:xfrm>
+            <a:off x="9331452" y="4800599"/>
+            <a:ext cx="1943100" cy="256032"/>
+          </a:xfrm>
+          <a:prstGeom prst="rect">
+            <a:avLst/>
+          </a:prstGeom>
+          <a:noFill/>
+        </p:spPr>
+        <p:txBody>
+          <a:bodyPr wrap="square" anchor="t" lIns="0" rIns="0" tIns="0" bIns="0">
+            <a:spAutoFit/>
+          </a:bodyPr>
+          <a:lstStyle/>
+          <a:p>
+            <a:pPr algn="l">
+              <a:lnSpc>
+                <a:spcPct val="125000"/>
+              </a:lnSpc>
+            </a:pPr>
+            <a:r>
+              <a:rPr b="1" sz="1400">
+                <a:solidFill>
+                  <a:srgbClr val="3987E5"/>
+                </a:solidFill>
+                <a:latin typeface="Arial"/>
+              </a:rPr>
+              <a:t>SEM SINAL</a:t>
+            </a:r>
+          </a:p>
+        </p:txBody>
+      </p:sp>
+      <p:sp>
+        <p:nvSpPr>
+          <p:cNvPr id="35" name="TextBox 34"/>
+          <p:cNvSpPr txBox="1"/>
+          <p:nvPr/>
+        </p:nvSpPr>
+        <p:spPr>
+          <a:xfrm>
+            <a:off x="6839712" y="5321807"/>
+            <a:ext cx="4471416" cy="457200"/>
+          </a:xfrm>
+          <a:prstGeom prst="rect">
+            <a:avLst/>
+          </a:prstGeom>
+          <a:noFill/>
+        </p:spPr>
+        <p:txBody>
+          <a:bodyPr wrap="square" anchor="t" lIns="0" rIns="0" tIns="0" bIns="0">
+            <a:spAutoFit/>
+          </a:bodyPr>
+          <a:lstStyle/>
+          <a:p>
+            <a:pPr algn="l">
+              <a:lnSpc>
+                <a:spcPct val="128000"/>
+              </a:lnSpc>
+            </a:pPr>
+            <a:r>
+              <a:rPr b="0" sz="1050">
+                <a:solidFill>
+                  <a:srgbClr val="52514E"/>
+                </a:solidFill>
+                <a:latin typeface="Arial"/>
+              </a:rPr>
+              <a:t>De 63 palavras, o dicionário só reconheceu </a:t>
+            </a:r>
+            <a:r>
+              <a:rPr b="1" sz="1050">
+                <a:solidFill>
+                  <a:srgbClr val="0B0B0B"/>
+                </a:solidFill>
+                <a:latin typeface="Arial"/>
+              </a:rPr>
+              <a:t>home</a:t>
+            </a:r>
+            <a:r>
+              <a:rPr b="0" sz="1050">
+                <a:solidFill>
+                  <a:srgbClr val="52514E"/>
+                </a:solidFill>
+                <a:latin typeface="Arial"/>
+              </a:rPr>
+              <a:t>. Os termos que dariam o tom — </a:t>
+            </a:r>
+            <a:r>
+              <a:rPr i="1" sz="1050">
+                <a:solidFill>
+                  <a:srgbClr val="52514E"/>
+                </a:solidFill>
+                <a:latin typeface="Arial"/>
+              </a:rPr>
+              <a:t>cries</a:t>
+            </a:r>
+            <a:r>
+              <a:rPr b="0" sz="1050">
+                <a:solidFill>
+                  <a:srgbClr val="52514E"/>
+                </a:solidFill>
+                <a:latin typeface="Arial"/>
+              </a:rPr>
+              <a:t>, </a:t>
+            </a:r>
+            <a:r>
+              <a:rPr i="1" sz="1050">
+                <a:solidFill>
+                  <a:srgbClr val="52514E"/>
+                </a:solidFill>
+                <a:latin typeface="Arial"/>
+              </a:rPr>
+              <a:t>evicts</a:t>
+            </a:r>
+            <a:r>
+              <a:rPr b="0" sz="1050">
+                <a:solidFill>
+                  <a:srgbClr val="52514E"/>
+                </a:solidFill>
+                <a:latin typeface="Arial"/>
+              </a:rPr>
+              <a:t>, </a:t>
+            </a:r>
+            <a:r>
+              <a:rPr i="1" sz="1050">
+                <a:solidFill>
+                  <a:srgbClr val="52514E"/>
+                </a:solidFill>
+                <a:latin typeface="Arial"/>
+              </a:rPr>
+              <a:t>protests</a:t>
+            </a:r>
+            <a:r>
+              <a:rPr b="0" sz="1050">
+                <a:solidFill>
+                  <a:srgbClr val="52514E"/>
+                </a:solidFill>
+                <a:latin typeface="Arial"/>
+              </a:rPr>
+              <a:t> — não estão no ANEW.</a:t>
+            </a:r>
+          </a:p>
+        </p:txBody>
+      </p:sp>
+      <p:cxnSp>
+        <p:nvCxnSpPr>
+          <p:cNvPr id="36" name="Connector 35"/>
+          <p:cNvCxnSpPr/>
+          <p:nvPr/>
+        </p:nvCxnSpPr>
+        <p:spPr>
+          <a:xfrm>
+            <a:off x="640080" y="6355080"/>
+            <a:ext cx="10911535" cy="0"/>
+          </a:xfrm>
+          <a:prstGeom prst="line">
+            <a:avLst/>
+          </a:prstGeom>
+          <a:ln w="9525">
+            <a:solidFill>
+              <a:srgbClr val="E1E0D9"/>
+            </a:solidFill>
+          </a:ln>
+        </p:spPr>
+        <p:style>
+          <a:lnRef idx="2">
+            <a:schemeClr val="accent1"/>
+          </a:lnRef>
+          <a:fillRef idx="0">
+            <a:schemeClr val="accent1"/>
+          </a:fillRef>
+          <a:effectRef idx="1">
+            <a:schemeClr val="accent1"/>
+          </a:effectRef>
+          <a:fontRef idx="minor">
+            <a:schemeClr val="tx1"/>
+          </a:fontRef>
+        </p:style>
+      </p:cxnSp>
+      <p:sp>
+        <p:nvSpPr>
+          <p:cNvPr id="37" name="TextBox 36"/>
+          <p:cNvSpPr txBox="1"/>
+          <p:nvPr/>
+        </p:nvSpPr>
+        <p:spPr>
+          <a:xfrm>
+            <a:off x="640080" y="6437376"/>
+            <a:ext cx="10454335" cy="274320"/>
+          </a:xfrm>
+          <a:prstGeom prst="rect">
+            <a:avLst/>
+          </a:prstGeom>
+          <a:noFill/>
+        </p:spPr>
+        <p:txBody>
+          <a:bodyPr wrap="square" anchor="t" lIns="0" rIns="0" tIns="0" bIns="0">
+            <a:spAutoFit/>
+          </a:bodyPr>
+          <a:lstStyle/>
+          <a:p>
+            <a:pPr algn="l">
+              <a:lnSpc>
+                <a:spcPct val="125000"/>
+              </a:lnSpc>
+            </a:pPr>
+            <a:r>
+              <a:rPr b="0" sz="850">
+                <a:solidFill>
+                  <a:srgbClr val="898781"/>
+                </a:solidFill>
+                <a:latin typeface="Arial"/>
+              </a:rPr>
+              <a:t>Cada escolha foi testada contra os posts reais antes de ser adotada</a:t>
+            </a:r>
+          </a:p>
+        </p:txBody>
+      </p:sp>
+      <p:sp>
+        <p:nvSpPr>
+          <p:cNvPr id="38" name="TextBox 37"/>
+          <p:cNvSpPr txBox="1"/>
+          <p:nvPr/>
+        </p:nvSpPr>
+        <p:spPr>
+          <a:xfrm>
+            <a:off x="11185855" y="6437376"/>
+            <a:ext cx="365760" cy="274320"/>
+          </a:xfrm>
+          <a:prstGeom prst="rect">
+            <a:avLst/>
+          </a:prstGeom>
+          <a:noFill/>
+        </p:spPr>
+        <p:txBody>
+          <a:bodyPr wrap="square" anchor="t" lIns="0" rIns="0" tIns="0" bIns="0">
+            <a:spAutoFit/>
+          </a:bodyPr>
+          <a:lstStyle/>
+          <a:p>
+            <a:pPr algn="r">
+              <a:lnSpc>
+                <a:spcPct val="125000"/>
+              </a:lnSpc>
+            </a:pPr>
+            <a:r>
+              <a:rPr b="0" sz="850">
+                <a:solidFill>
+                  <a:srgbClr val="898781"/>
+                </a:solidFill>
+                <a:latin typeface="Arial"/>
+              </a:rPr>
+              <a:t>2</a:t>
+            </a:r>
+          </a:p>
+        </p:txBody>
+      </p:sp>
+    </p:spTree>
+  </p:cSld>
+  <p:clrMapOvr>
+    <a:masterClrMapping/>
+  </p:clrMapOvr>
+</p:sld>
+</file>
+
+<file path=ppt/slides/slide4.xml><?xml version="1.0" encoding="utf-8"?>
+<p:sld xmlns:a="http://schemas.openxmlformats.org/drawingml/2006/main" xmlns:p="http://schemas.openxmlformats.org/presentationml/2006/main" xmlns:r="http://schemas.openxmlformats.org/officeDocument/2006/relationships">
+  <p:cSld>
+    <p:spTree>
+      <p:nvGrpSpPr>
+        <p:cNvPr id="1" name=""/>
+        <p:cNvGrpSpPr/>
+        <p:nvPr/>
+      </p:nvGrpSpPr>
+      <p:grpSpPr/>
+      <p:sp>
+        <p:nvSpPr>
+          <p:cNvPr id="2" name="Rectangle 1"/>
+          <p:cNvSpPr/>
+          <p:nvPr/>
+        </p:nvSpPr>
+        <p:spPr>
+          <a:xfrm>
+            <a:off x="0" y="0"/>
+            <a:ext cx="12191695" cy="6858000"/>
+          </a:xfrm>
+          <a:prstGeom prst="rect">
+            <a:avLst/>
+          </a:prstGeom>
+          <a:solidFill>
+            <a:srgbClr val="FCFCFB"/>
+          </a:solidFill>
+          <a:ln>
+            <a:noFill/>
+          </a:ln>
+          <a:effectLst/>
+        </p:spPr>
+        <p:style>
+          <a:lnRef idx="1">
+            <a:schemeClr val="accent1"/>
+          </a:lnRef>
+          <a:fillRef idx="3">
+            <a:schemeClr val="accent1"/>
+          </a:fillRef>
+          <a:effectRef idx="2">
+            <a:schemeClr val="accent1"/>
+          </a:effectRef>
+          <a:fontRef idx="minor">
+            <a:schemeClr val="lt1"/>
+          </a:fontRef>
+        </p:style>
+        <p:txBody>
+          <a:bodyPr rtlCol="0" anchor="ctr"/>
+          <a:lstStyle/>
+          <a:p/>
+        </p:txBody>
+      </p:sp>
+      <p:sp>
+        <p:nvSpPr>
+          <p:cNvPr id="3" name="TextBox 2"/>
+          <p:cNvSpPr txBox="1"/>
+          <p:nvPr/>
+        </p:nvSpPr>
+        <p:spPr>
+          <a:xfrm>
+            <a:off x="640080" y="502920"/>
+            <a:ext cx="10911535" cy="548640"/>
+          </a:xfrm>
+          <a:prstGeom prst="rect">
+            <a:avLst/>
+          </a:prstGeom>
+          <a:noFill/>
+        </p:spPr>
+        <p:txBody>
+          <a:bodyPr wrap="square" lIns="0" rIns="0" tIns="0" bIns="0">
+            <a:spAutoFit/>
+          </a:bodyPr>
+          <a:lstStyle/>
+          <a:p>
+            <a:pPr>
+              <a:lnSpc>
+                <a:spcPct val="110000"/>
+              </a:lnSpc>
+            </a:pPr>
+            <a:r>
+              <a:rPr sz="2700" b="1">
+                <a:solidFill>
+                  <a:srgbClr val="0B0B0B"/>
+                </a:solidFill>
+                <a:latin typeface="Arial"/>
+              </a:rPr>
+              <a:t>Fala-se mais bem que mal da Argentina</a:t>
+            </a:r>
+          </a:p>
+        </p:txBody>
+      </p:sp>
+      <p:sp>
+        <p:nvSpPr>
+          <p:cNvPr id="4" name="TextBox 3"/>
+          <p:cNvSpPr txBox="1"/>
+          <p:nvPr/>
+        </p:nvSpPr>
+        <p:spPr>
+          <a:xfrm>
+            <a:off x="640080" y="1078992"/>
+            <a:ext cx="10911535" cy="457200"/>
+          </a:xfrm>
+          <a:prstGeom prst="rect">
+            <a:avLst/>
+          </a:prstGeom>
+          <a:noFill/>
+        </p:spPr>
+        <p:txBody>
+          <a:bodyPr wrap="square" anchor="t" lIns="0" rIns="0" tIns="0" bIns="0">
+            <a:spAutoFit/>
+          </a:bodyPr>
+          <a:lstStyle/>
+          <a:p>
+            <a:pPr algn="l">
+              <a:lnSpc>
+                <a:spcPct val="130000"/>
+              </a:lnSpc>
+            </a:pPr>
+            <a:r>
+              <a:rPr b="0" sz="1250">
+                <a:solidFill>
+                  <a:srgbClr val="898781"/>
+                </a:solidFill>
+                <a:latin typeface="Arial"/>
+              </a:rPr>
+              <a:t>308 posts classificados, de 632 em inglês. Mais da metade é positiva e quatro em cada dez ficam no meio da escala. Crítica forte é rara: 3%.</a:t>
+            </a:r>
+          </a:p>
+        </p:txBody>
+      </p:sp>
       <p:pic>
         <p:nvPicPr>
-          <p:cNvPr id="2" name="Picture 1" descr="slide3.png"/>
+          <p:cNvPr id="5" name="Picture 4" descr="sentimento.png"/>
           <p:cNvPicPr>
             <a:picLocks noChangeAspect="1"/>
           </p:cNvPicPr>
@@ -3190,14 +6534,127 @@
         </p:blipFill>
         <p:spPr>
           <a:xfrm>
-            <a:off x="0" y="0"/>
-            <a:ext cx="12192000" cy="6858000"/>
+            <a:off x="1432407" y="1737360"/>
+            <a:ext cx="9326880" cy="4437790"/>
           </a:xfrm>
           <a:prstGeom prst="rect">
             <a:avLst/>
           </a:prstGeom>
         </p:spPr>
       </p:pic>
+      <p:cxnSp>
+        <p:nvCxnSpPr>
+          <p:cNvPr id="6" name="Connector 5"/>
+          <p:cNvCxnSpPr/>
+          <p:nvPr/>
+        </p:nvCxnSpPr>
+        <p:spPr>
+          <a:xfrm>
+            <a:off x="640080" y="6355080"/>
+            <a:ext cx="10911535" cy="0"/>
+          </a:xfrm>
+          <a:prstGeom prst="line">
+            <a:avLst/>
+          </a:prstGeom>
+          <a:ln w="9525">
+            <a:solidFill>
+              <a:srgbClr val="E1E0D9"/>
+            </a:solidFill>
+          </a:ln>
+        </p:spPr>
+        <p:style>
+          <a:lnRef idx="2">
+            <a:schemeClr val="accent1"/>
+          </a:lnRef>
+          <a:fillRef idx="0">
+            <a:schemeClr val="accent1"/>
+          </a:fillRef>
+          <a:effectRef idx="1">
+            <a:schemeClr val="accent1"/>
+          </a:effectRef>
+          <a:fontRef idx="minor">
+            <a:schemeClr val="tx1"/>
+          </a:fontRef>
+        </p:style>
+      </p:cxnSp>
+      <p:sp>
+        <p:nvSpPr>
+          <p:cNvPr id="7" name="TextBox 6"/>
+          <p:cNvSpPr txBox="1"/>
+          <p:nvPr/>
+        </p:nvSpPr>
+        <p:spPr>
+          <a:xfrm>
+            <a:off x="640080" y="6437376"/>
+            <a:ext cx="10454335" cy="274320"/>
+          </a:xfrm>
+          <a:prstGeom prst="rect">
+            <a:avLst/>
+          </a:prstGeom>
+          <a:noFill/>
+        </p:spPr>
+        <p:txBody>
+          <a:bodyPr wrap="square" anchor="t" lIns="0" rIns="0" tIns="0" bIns="0">
+            <a:spAutoFit/>
+          </a:bodyPr>
+          <a:lstStyle/>
+          <a:p>
+            <a:pPr algn="l">
+              <a:lnSpc>
+                <a:spcPct val="125000"/>
+              </a:lnSpc>
+            </a:pPr>
+            <a:r>
+              <a:rPr b="0" sz="850">
+                <a:solidFill>
+                  <a:srgbClr val="898781"/>
+                </a:solidFill>
+                <a:latin typeface="Arial"/>
+              </a:rPr>
+              <a:t>2.400 posts baixados · 632 confirmados em inglês · 308 com palavras suficientes para pontuar</a:t>
+            </a:r>
+          </a:p>
+        </p:txBody>
+      </p:sp>
+      <p:sp>
+        <p:nvSpPr>
+          <p:cNvPr id="8" name="TextBox 7"/>
+          <p:cNvSpPr txBox="1"/>
+          <p:nvPr/>
+        </p:nvSpPr>
+        <p:spPr>
+          <a:xfrm>
+            <a:off x="11185855" y="6437376"/>
+            <a:ext cx="365760" cy="274320"/>
+          </a:xfrm>
+          <a:prstGeom prst="rect">
+            <a:avLst/>
+          </a:prstGeom>
+          <a:noFill/>
+        </p:spPr>
+        <p:txBody>
+          <a:bodyPr wrap="square" anchor="t" lIns="0" rIns="0" tIns="0" bIns="0">
+            <a:spAutoFit/>
+          </a:bodyPr>
+          <a:lstStyle/>
+          <a:p>
+            <a:pPr algn="r">
+              <a:lnSpc>
+                <a:spcPct val="125000"/>
+              </a:lnSpc>
+            </a:pPr>
+            <a:r>
+              <a:rPr b="0" sz="850">
+                <a:solidFill>
+                  <a:srgbClr val="898781"/>
+                </a:solidFill>
+                <a:latin typeface="Arial"/>
+              </a:rPr>
+              <a:t>3</a:t>
+            </a:r>
+          </a:p>
+        </p:txBody>
+      </p:sp>
     </p:spTree>
   </p:cSld>
   <p:clrMapOvr>

</xml_diff>